<commit_message>
ppt slide numbers and notes
</commit_message>
<xml_diff>
--- a/docs/FoodBridge_Project_Review.pptx
+++ b/docs/FoodBridge_Project_Review.pptx
@@ -2,22 +2,22 @@
 <file path=ppt/presentation.xml><?xml version="1.0" encoding="utf-8"?>
 <p:presentation xmlns:p="http://schemas.openxmlformats.org/presentationml/2006/main">
   <p:sldMasterIdLst>
-    <p:sldMasterId xmlns:r="http://schemas.openxmlformats.org/officeDocument/2006/relationships" id="2147483648" r:id="R34ddb6235a8e492f"/>
+    <p:sldMasterId xmlns:r="http://schemas.openxmlformats.org/officeDocument/2006/relationships" id="2147483648" r:id="R2997cc355cf4414a"/>
   </p:sldMasterIdLst>
   <p:notesMasterIdLst>
-    <p:notesMasterId xmlns:r="http://schemas.openxmlformats.org/officeDocument/2006/relationships" r:id="R88608b788eff4a39"/>
+    <p:notesMasterId xmlns:r="http://schemas.openxmlformats.org/officeDocument/2006/relationships" r:id="Rd2bcf79e84c74f9e"/>
   </p:notesMasterIdLst>
   <p:sldIdLst>
-    <p:sldId xmlns:r="http://schemas.openxmlformats.org/officeDocument/2006/relationships" id="256" r:id="R7cfb1b3f8152482b"/>
-    <p:sldId xmlns:r="http://schemas.openxmlformats.org/officeDocument/2006/relationships" id="257" r:id="R3104b29e4ea8412b"/>
-    <p:sldId xmlns:r="http://schemas.openxmlformats.org/officeDocument/2006/relationships" id="258" r:id="Reebcf2dc49674160"/>
-    <p:sldId xmlns:r="http://schemas.openxmlformats.org/officeDocument/2006/relationships" id="259" r:id="R6705056787b04162"/>
-    <p:sldId xmlns:r="http://schemas.openxmlformats.org/officeDocument/2006/relationships" id="260" r:id="Rdcd19829219c4a3b"/>
-    <p:sldId xmlns:r="http://schemas.openxmlformats.org/officeDocument/2006/relationships" id="261" r:id="Ra1970b71e3e246f7"/>
-    <p:sldId xmlns:r="http://schemas.openxmlformats.org/officeDocument/2006/relationships" id="262" r:id="Re9e0b390fdcd4563"/>
-    <p:sldId xmlns:r="http://schemas.openxmlformats.org/officeDocument/2006/relationships" id="263" r:id="Rfbe6cbd320be4e34"/>
-    <p:sldId xmlns:r="http://schemas.openxmlformats.org/officeDocument/2006/relationships" id="264" r:id="R93ab7a1426f141a4"/>
-    <p:sldId xmlns:r="http://schemas.openxmlformats.org/officeDocument/2006/relationships" id="265" r:id="Rc9943d0f5ae74d93"/>
+    <p:sldId xmlns:r="http://schemas.openxmlformats.org/officeDocument/2006/relationships" id="256" r:id="R40df262a2a3e4ef3"/>
+    <p:sldId xmlns:r="http://schemas.openxmlformats.org/officeDocument/2006/relationships" id="257" r:id="R233ec4bf111542d4"/>
+    <p:sldId xmlns:r="http://schemas.openxmlformats.org/officeDocument/2006/relationships" id="258" r:id="Rded3c8e24b1f4e2a"/>
+    <p:sldId xmlns:r="http://schemas.openxmlformats.org/officeDocument/2006/relationships" id="259" r:id="Ra893f3e762c146cd"/>
+    <p:sldId xmlns:r="http://schemas.openxmlformats.org/officeDocument/2006/relationships" id="260" r:id="R8c03a03c7c6e44f3"/>
+    <p:sldId xmlns:r="http://schemas.openxmlformats.org/officeDocument/2006/relationships" id="261" r:id="R1b57c96a11f24bab"/>
+    <p:sldId xmlns:r="http://schemas.openxmlformats.org/officeDocument/2006/relationships" id="262" r:id="Rbd94185ed086440f"/>
+    <p:sldId xmlns:r="http://schemas.openxmlformats.org/officeDocument/2006/relationships" id="263" r:id="R632005beed55401f"/>
+    <p:sldId xmlns:r="http://schemas.openxmlformats.org/officeDocument/2006/relationships" id="264" r:id="R1a16d6aaf07c4d6f"/>
+    <p:sldId xmlns:r="http://schemas.openxmlformats.org/officeDocument/2006/relationships" id="265" r:id="R16e7be827af54dd6"/>
   </p:sldIdLst>
   <p:sldSz cx="12192000" cy="6858000"/>
   <p:notesSz cx="6858000" cy="9144000"/>
@@ -451,7 +451,7 @@
           <a:lstStyle xmlns:a="http://schemas.openxmlformats.org/drawingml/2006/main"/>
           <a:p xmlns:a="http://schemas.openxmlformats.org/drawingml/2006/main">
             <a:r>
-              <a:t>Cover. State the project title and the two questions the review answers: how the platform works, and what distinguishes it.</a:t>
+              <a:t>About 10 seconds. Title, then one sentence: this review covers how the platform works and what distinguishes it. Move on quickly.</a:t>
             </a:r>
           </a:p>
         </p:txBody>
@@ -521,7 +521,7 @@
           <a:lstStyle xmlns:a="http://schemas.openxmlformats.org/drawingml/2006/main"/>
           <a:p xmlns:a="http://schemas.openxmlformats.org/drawingml/2006/main">
             <a:r>
-              <a:t>Close the slides here and begin the live demonstration of the platform.</a:t>
+              <a:t>About 20 seconds, then switch to the live demonstration. Open localhost:5173, sign in as administrator, open the Allocation Engine and use the urgent donation at the top of the queue. Preview decision reproduces the table on slide 6, then Run and allocate. Sign in as the recipient to accept, as the volunteer to collect, deliver and mark it delivered, then as the recipient again to confirm receipt. Finish on Reports and Analytics for the figures on slide 9.</a:t>
             </a:r>
           </a:p>
         </p:txBody>
@@ -591,7 +591,7 @@
           <a:lstStyle xmlns:a="http://schemas.openxmlformats.org/drawingml/2006/main"/>
           <a:p xmlns:a="http://schemas.openxmlformats.org/drawingml/2006/main">
             <a:r>
-              <a:t>The final two points define the problem this project addresses: safety and justification are absent from existing platforms.</a:t>
+              <a:t>About 30 seconds. The last two points are the gap this project fills: safety and justification. Do not elaborate here, slide 3 covers it.</a:t>
             </a:r>
           </a:p>
         </p:txBody>
@@ -659,7 +659,11 @@
         <p:txBody>
           <a:bodyPr xmlns:a="http://schemas.openxmlformats.org/drawingml/2006/main"/>
           <a:lstStyle xmlns:a="http://schemas.openxmlformats.org/drawingml/2006/main"/>
-          <a:p xmlns:a="http://schemas.openxmlformats.org/drawingml/2006/main"/>
+          <a:p xmlns:a="http://schemas.openxmlformats.org/drawingml/2006/main">
+            <a:r>
+              <a:t>About 40 seconds, and the main emphasis of the review. Read two rows only and state that the remaining four are in the table.</a:t>
+            </a:r>
+          </a:p>
         </p:txBody>
       </p:sp>
       <p:sp>
@@ -725,7 +729,11 @@
         <p:txBody>
           <a:bodyPr xmlns:a="http://schemas.openxmlformats.org/drawingml/2006/main"/>
           <a:lstStyle xmlns:a="http://schemas.openxmlformats.org/drawingml/2006/main"/>
-          <a:p xmlns:a="http://schemas.openxmlformats.org/drawingml/2006/main"/>
+          <a:p xmlns:a="http://schemas.openxmlformats.org/drawingml/2006/main">
+            <a:r>
+              <a:t>About 25 seconds. Name the four actors and the sequence; the demonstration follows the same path on screen.</a:t>
+            </a:r>
+          </a:p>
         </p:txBody>
       </p:sp>
       <p:sp>
@@ -791,7 +799,11 @@
         <p:txBody>
           <a:bodyPr xmlns:a="http://schemas.openxmlformats.org/drawingml/2006/main"/>
           <a:lstStyle xmlns:a="http://schemas.openxmlformats.org/drawingml/2006/main"/>
-          <a:p xmlns:a="http://schemas.openxmlformats.org/drawingml/2006/main"/>
+          <a:p xmlns:a="http://schemas.openxmlformats.org/drawingml/2006/main">
+            <a:r>
+              <a:t>About 40 seconds. The four constraints first, then the six factors. Do not read every row aloud.</a:t>
+            </a:r>
+          </a:p>
         </p:txBody>
       </p:sp>
       <p:sp>
@@ -859,7 +871,7 @@
           <a:lstStyle xmlns:a="http://schemas.openxmlformats.org/drawingml/2006/main"/>
           <a:p xmlns:a="http://schemas.openxmlformats.org/drawingml/2006/main">
             <a:r>
-              <a:t>This is the answer to the question of original contribution. The three assumptions are the values the rule depends on.</a:t>
+              <a:t>About 50 seconds, the key slide. State the rule, explain why it is a hard constraint rather than a score, give the three assumptions, then the recorded result.</a:t>
             </a:r>
           </a:p>
         </p:txBody>
@@ -927,7 +939,11 @@
         <p:txBody>
           <a:bodyPr xmlns:a="http://schemas.openxmlformats.org/drawingml/2006/main"/>
           <a:lstStyle xmlns:a="http://schemas.openxmlformats.org/drawingml/2006/main"/>
-          <a:p xmlns:a="http://schemas.openxmlformats.org/drawingml/2006/main"/>
+          <a:p xmlns:a="http://schemas.openxmlformats.org/drawingml/2006/main">
+            <a:r>
+              <a:t>About 30 seconds. Point at the submitted diagram, name the four layers, and mention JWT and the server side checks.</a:t>
+            </a:r>
+          </a:p>
         </p:txBody>
       </p:sp>
       <p:sp>
@@ -993,7 +1009,11 @@
         <p:txBody>
           <a:bodyPr xmlns:a="http://schemas.openxmlformats.org/drawingml/2006/main"/>
           <a:lstStyle xmlns:a="http://schemas.openxmlformats.org/drawingml/2006/main"/>
-          <a:p xmlns:a="http://schemas.openxmlformats.org/drawingml/2006/main"/>
+          <a:p xmlns:a="http://schemas.openxmlformats.org/drawingml/2006/main">
+            <a:r>
+              <a:t>About 25 seconds. Twelve entities in third normal form, and the reason allocation, assignment and delivery are separate.</a:t>
+            </a:r>
+          </a:p>
         </p:txBody>
       </p:sp>
       <p:sp>
@@ -1059,7 +1079,11 @@
         <p:txBody>
           <a:bodyPr xmlns:a="http://schemas.openxmlformats.org/drawingml/2006/main"/>
           <a:lstStyle xmlns:a="http://schemas.openxmlformats.org/drawingml/2006/main"/>
-          <a:p xmlns:a="http://schemas.openxmlformats.org/drawingml/2006/main"/>
+          <a:p xmlns:a="http://schemas.openxmlformats.org/drawingml/2006/main">
+            <a:r>
+              <a:t>About 30 seconds. Read two or three figures, then the verification lines. The live reports reproduce these numbers.</a:t>
+            </a:r>
+          </a:p>
         </p:txBody>
       </p:sp>
       <p:sp>
@@ -1104,7 +1128,7 @@
           <p:cNvPr id="3" name="Title">
             <a:extLst xmlns:a="http://schemas.openxmlformats.org/drawingml/2006/main">
               <a:ext uri="{FF2B5EF4-FFF2-40B4-BE49-F238E27FC236}">
-                <a16:creationId xmlns:a16="http://schemas.microsoft.com/office/drawing/2014/main" id="{F76F41E0-EB6A-4B3A-B63B-727BBBEDAA6A}"/>
+                <a16:creationId xmlns:a16="http://schemas.microsoft.com/office/drawing/2014/main" id="{30F08FFD-D713-4721-9E97-5AB140AC5DB1}"/>
               </a:ext>
             </a:extLst>
           </p:cNvPr>
@@ -1261,7 +1285,7 @@
           <p:cNvPr id="2" name="Subtitle">
             <a:extLst xmlns:a="http://schemas.openxmlformats.org/drawingml/2006/main">
               <a:ext uri="{FF2B5EF4-FFF2-40B4-BE49-F238E27FC236}">
-                <a16:creationId xmlns:a16="http://schemas.microsoft.com/office/drawing/2014/main" id="{260467F6-8D23-4138-BA55-951E84DA3011}"/>
+                <a16:creationId xmlns:a16="http://schemas.microsoft.com/office/drawing/2014/main" id="{3DC2C094-D7DE-4BB8-A9CD-E3B5B918F7B0}"/>
               </a:ext>
             </a:extLst>
           </p:cNvPr>
@@ -1435,7 +1459,7 @@
           <p:cNvPr id="2" name="Section title">
             <a:extLst xmlns:a="http://schemas.openxmlformats.org/drawingml/2006/main">
               <a:ext uri="{FF2B5EF4-FFF2-40B4-BE49-F238E27FC236}">
-                <a16:creationId xmlns:a16="http://schemas.microsoft.com/office/drawing/2014/main" id="{EAE30AA0-AA9C-4819-8F41-BDA9E55F9CE4}"/>
+                <a16:creationId xmlns:a16="http://schemas.microsoft.com/office/drawing/2014/main" id="{9D5566E6-6036-4B71-8FCC-FBF0046A71A8}"/>
               </a:ext>
             </a:extLst>
           </p:cNvPr>
@@ -1609,7 +1633,7 @@
           <p:cNvPr id="3" name="Title">
             <a:extLst xmlns:a="http://schemas.openxmlformats.org/drawingml/2006/main">
               <a:ext uri="{FF2B5EF4-FFF2-40B4-BE49-F238E27FC236}">
-                <a16:creationId xmlns:a16="http://schemas.microsoft.com/office/drawing/2014/main" id="{E8D4F5C0-A614-42E9-B519-BCB2D0D471F4}"/>
+                <a16:creationId xmlns:a16="http://schemas.microsoft.com/office/drawing/2014/main" id="{177EA7C1-0D6E-4ABA-B5BF-BA3F2EC331F7}"/>
               </a:ext>
             </a:extLst>
           </p:cNvPr>
@@ -1766,7 +1790,7 @@
           <p:cNvPr id="2" name="Body">
             <a:extLst xmlns:a="http://schemas.openxmlformats.org/drawingml/2006/main">
               <a:ext uri="{FF2B5EF4-FFF2-40B4-BE49-F238E27FC236}">
-                <a16:creationId xmlns:a16="http://schemas.microsoft.com/office/drawing/2014/main" id="{7BBFDA2F-A41B-4966-AD49-0169D8C3D63F}"/>
+                <a16:creationId xmlns:a16="http://schemas.microsoft.com/office/drawing/2014/main" id="{E87538EC-4139-475F-B8DB-71A4084B9CC8}"/>
               </a:ext>
             </a:extLst>
           </p:cNvPr>
@@ -1940,7 +1964,7 @@
           <p:cNvPr id="4" name="Title">
             <a:extLst xmlns:a="http://schemas.openxmlformats.org/drawingml/2006/main">
               <a:ext uri="{FF2B5EF4-FFF2-40B4-BE49-F238E27FC236}">
-                <a16:creationId xmlns:a16="http://schemas.microsoft.com/office/drawing/2014/main" id="{D37D4087-6501-4261-BF3B-B5313709068B}"/>
+                <a16:creationId xmlns:a16="http://schemas.microsoft.com/office/drawing/2014/main" id="{F6C19DE9-D2A4-4459-90FB-04DF018F7D93}"/>
               </a:ext>
             </a:extLst>
           </p:cNvPr>
@@ -2097,7 +2121,7 @@
           <p:cNvPr id="2" name="Left column">
             <a:extLst xmlns:a="http://schemas.openxmlformats.org/drawingml/2006/main">
               <a:ext uri="{FF2B5EF4-FFF2-40B4-BE49-F238E27FC236}">
-                <a16:creationId xmlns:a16="http://schemas.microsoft.com/office/drawing/2014/main" id="{C6E39595-AB7D-415B-85C7-FEA65006FDB7}"/>
+                <a16:creationId xmlns:a16="http://schemas.microsoft.com/office/drawing/2014/main" id="{F8E6F062-37FD-494A-84C7-35F4501A9BFB}"/>
               </a:ext>
             </a:extLst>
           </p:cNvPr>
@@ -2254,7 +2278,7 @@
           <p:cNvPr id="3" name="Right column">
             <a:extLst xmlns:a="http://schemas.openxmlformats.org/drawingml/2006/main">
               <a:ext uri="{FF2B5EF4-FFF2-40B4-BE49-F238E27FC236}">
-                <a16:creationId xmlns:a16="http://schemas.microsoft.com/office/drawing/2014/main" id="{62CE44A6-2AF7-43E6-BC73-7D359C6FD7ED}"/>
+                <a16:creationId xmlns:a16="http://schemas.microsoft.com/office/drawing/2014/main" id="{7A93EA39-7F03-4B66-AF6B-B58250CEB79C}"/>
               </a:ext>
             </a:extLst>
           </p:cNvPr>
@@ -2428,7 +2452,7 @@
           <p:cNvPr id="3" name="Title">
             <a:extLst xmlns:a="http://schemas.openxmlformats.org/drawingml/2006/main">
               <a:ext uri="{FF2B5EF4-FFF2-40B4-BE49-F238E27FC236}">
-                <a16:creationId xmlns:a16="http://schemas.microsoft.com/office/drawing/2014/main" id="{1CBE46C0-8A1B-4332-8C04-9F56E5B67FDB}"/>
+                <a16:creationId xmlns:a16="http://schemas.microsoft.com/office/drawing/2014/main" id="{6BAD64C7-91F4-4E47-B31B-4769D9E76947}"/>
               </a:ext>
             </a:extLst>
           </p:cNvPr>
@@ -2585,7 +2609,7 @@
           <p:cNvPr id="2" name="Left column">
             <a:extLst xmlns:a="http://schemas.openxmlformats.org/drawingml/2006/main">
               <a:ext uri="{FF2B5EF4-FFF2-40B4-BE49-F238E27FC236}">
-                <a16:creationId xmlns:a16="http://schemas.microsoft.com/office/drawing/2014/main" id="{68FD1876-B446-46A3-991F-6FD7E435C1BB}"/>
+                <a16:creationId xmlns:a16="http://schemas.microsoft.com/office/drawing/2014/main" id="{3C558B3D-99C7-45AD-A762-2D111D3399F2}"/>
               </a:ext>
             </a:extLst>
           </p:cNvPr>
@@ -2780,12 +2804,12 @@
   </p:cSld>
   <p:clrMap bg1="lt1" tx1="dk1" bg2="lt2" tx2="dk2" accent1="accent1" accent2="accent2" accent3="accent3" accent4="accent4" accent5="accent5" accent6="accent6" hlink="hlink" folHlink="folHlink"/>
   <p:sldLayoutIdLst>
-    <p:sldLayoutId xmlns:r="http://schemas.openxmlformats.org/officeDocument/2006/relationships" id="2147483649" r:id="Rcbee40ce7de84947"/>
-    <p:sldLayoutId xmlns:r="http://schemas.openxmlformats.org/officeDocument/2006/relationships" id="2147483650" r:id="Re6b8b4761d0b45d7"/>
-    <p:sldLayoutId xmlns:r="http://schemas.openxmlformats.org/officeDocument/2006/relationships" id="2147483651" r:id="R11390447112e4fcc"/>
-    <p:sldLayoutId xmlns:r="http://schemas.openxmlformats.org/officeDocument/2006/relationships" id="2147483652" r:id="R1755882daf954b7b"/>
-    <p:sldLayoutId xmlns:r="http://schemas.openxmlformats.org/officeDocument/2006/relationships" id="2147483653" r:id="R8f342d6136d840a2"/>
-    <p:sldLayoutId xmlns:r="http://schemas.openxmlformats.org/officeDocument/2006/relationships" id="2147483654" r:id="Re2ec0d9b3b174254"/>
+    <p:sldLayoutId xmlns:r="http://schemas.openxmlformats.org/officeDocument/2006/relationships" id="2147483649" r:id="Ra9d05586b4b84d72"/>
+    <p:sldLayoutId xmlns:r="http://schemas.openxmlformats.org/officeDocument/2006/relationships" id="2147483650" r:id="R4449b291464b4533"/>
+    <p:sldLayoutId xmlns:r="http://schemas.openxmlformats.org/officeDocument/2006/relationships" id="2147483651" r:id="R53cbe0be4ae74ab7"/>
+    <p:sldLayoutId xmlns:r="http://schemas.openxmlformats.org/officeDocument/2006/relationships" id="2147483652" r:id="R35febde9cede47eb"/>
+    <p:sldLayoutId xmlns:r="http://schemas.openxmlformats.org/officeDocument/2006/relationships" id="2147483653" r:id="Rac435a57b8cd4661"/>
+    <p:sldLayoutId xmlns:r="http://schemas.openxmlformats.org/officeDocument/2006/relationships" id="2147483654" r:id="Rfde13663878749ac"/>
   </p:sldLayoutIdLst>
   <p:txStyles>
     <p:titleStyle>
@@ -3336,7 +3360,7 @@
           <p:cNvPr id="7" name="">
             <a:extLst xmlns:a="http://schemas.openxmlformats.org/drawingml/2006/main">
               <a:ext uri="{FF2B5EF4-FFF2-40B4-BE49-F238E27FC236}">
-                <a16:creationId xmlns:a16="http://schemas.microsoft.com/office/drawing/2014/main" id="{41447E2A-BD34-4234-B648-8DD32AB33AD3}"/>
+                <a16:creationId xmlns:a16="http://schemas.microsoft.com/office/drawing/2014/main" id="{7803F117-FB4F-41BB-88EC-F216E1374F89}"/>
               </a:ext>
             </a:extLst>
           </p:cNvPr>
@@ -3346,7 +3370,7 @@
           <p:nvPr/>
         </p:nvPicPr>
         <p:blipFill>
-          <a:blip xmlns:r="http://schemas.openxmlformats.org/officeDocument/2006/relationships" xmlns:a="http://schemas.openxmlformats.org/drawingml/2006/main" r:embed="R47a163051683434f"/>
+          <a:blip xmlns:r="http://schemas.openxmlformats.org/officeDocument/2006/relationships" xmlns:a="http://schemas.openxmlformats.org/drawingml/2006/main" r:embed="R8d1bf92740da4f39"/>
           <a:stretch xmlns:a="http://schemas.openxmlformats.org/drawingml/2006/main"/>
         </p:blipFill>
         <p:spPr>
@@ -3364,7 +3388,7 @@
           <p:cNvPr id="2" name="">
             <a:extLst xmlns:a="http://schemas.openxmlformats.org/drawingml/2006/main">
               <a:ext uri="{FF2B5EF4-FFF2-40B4-BE49-F238E27FC236}">
-                <a16:creationId xmlns:a16="http://schemas.microsoft.com/office/drawing/2014/main" id="{CE7B3210-A2BD-4A08-AD99-8B7544ED3EFF}"/>
+                <a16:creationId xmlns:a16="http://schemas.microsoft.com/office/drawing/2014/main" id="{AAA83703-9E42-40EF-B447-E363702170F0}"/>
               </a:ext>
             </a:extLst>
           </p:cNvPr>
@@ -3433,7 +3457,7 @@
           <p:cNvPr id="3" name="">
             <a:extLst xmlns:a="http://schemas.openxmlformats.org/drawingml/2006/main">
               <a:ext uri="{FF2B5EF4-FFF2-40B4-BE49-F238E27FC236}">
-                <a16:creationId xmlns:a16="http://schemas.microsoft.com/office/drawing/2014/main" id="{FB0029A7-A8DB-4088-A41A-8F7173791542}"/>
+                <a16:creationId xmlns:a16="http://schemas.microsoft.com/office/drawing/2014/main" id="{CC934BD5-1681-4A98-BC02-97A60A127340}"/>
               </a:ext>
             </a:extLst>
           </p:cNvPr>
@@ -3502,7 +3526,7 @@
           <p:cNvPr id="4" name="">
             <a:extLst xmlns:a="http://schemas.openxmlformats.org/drawingml/2006/main">
               <a:ext uri="{FF2B5EF4-FFF2-40B4-BE49-F238E27FC236}">
-                <a16:creationId xmlns:a16="http://schemas.microsoft.com/office/drawing/2014/main" id="{4C995206-7948-4D52-BEB1-5A358BD4839C}"/>
+                <a16:creationId xmlns:a16="http://schemas.microsoft.com/office/drawing/2014/main" id="{3769B8AC-9181-4849-B744-A9F89E03D301}"/>
               </a:ext>
             </a:extLst>
           </p:cNvPr>
@@ -3533,7 +3557,7 @@
           <p:cNvPr id="5" name="">
             <a:extLst xmlns:a="http://schemas.openxmlformats.org/drawingml/2006/main">
               <a:ext uri="{FF2B5EF4-FFF2-40B4-BE49-F238E27FC236}">
-                <a16:creationId xmlns:a16="http://schemas.microsoft.com/office/drawing/2014/main" id="{27598159-8E5F-4479-A90D-23CB897E27FB}"/>
+                <a16:creationId xmlns:a16="http://schemas.microsoft.com/office/drawing/2014/main" id="{F44584E7-6E51-4A37-AD76-9DDF126D8DFE}"/>
               </a:ext>
             </a:extLst>
           </p:cNvPr>
@@ -3602,7 +3626,7 @@
           <p:cNvPr id="6" name="">
             <a:extLst xmlns:a="http://schemas.openxmlformats.org/drawingml/2006/main">
               <a:ext uri="{FF2B5EF4-FFF2-40B4-BE49-F238E27FC236}">
-                <a16:creationId xmlns:a16="http://schemas.microsoft.com/office/drawing/2014/main" id="{2B4777DE-E874-4CB3-9A81-E9B175F21C8C}"/>
+                <a16:creationId xmlns:a16="http://schemas.microsoft.com/office/drawing/2014/main" id="{5CA4C4E8-F0AD-4BFD-94D0-CBDEF1D3806D}"/>
               </a:ext>
             </a:extLst>
           </p:cNvPr>
@@ -3669,7 +3693,7 @@
     </p:spTree>
     <p:extLst>
       <p:ext uri="{BB962C8B-B14F-4D97-AF65-F5344CB8AC3E}">
-        <p14:creationId xmlns:p14="http://schemas.microsoft.com/office/powerpoint/2010/main" val="834215799"/>
+        <p14:creationId xmlns:p14="http://schemas.microsoft.com/office/powerpoint/2010/main" val="1264910561"/>
       </p:ext>
     </p:extLst>
   </p:cSld>
@@ -3697,10 +3721,79 @@
       </p:grpSpPr>
       <p:sp>
         <p:nvSpPr>
-          <p:cNvPr id="8" name="slide-title">
+          <p:cNvPr id="9" name="">
             <a:extLst xmlns:a="http://schemas.openxmlformats.org/drawingml/2006/main">
               <a:ext uri="{FF2B5EF4-FFF2-40B4-BE49-F238E27FC236}">
-                <a16:creationId xmlns:a16="http://schemas.microsoft.com/office/drawing/2014/main" id="{CADFF864-8CBD-4879-AC33-4336B4973314}"/>
+                <a16:creationId xmlns:a16="http://schemas.microsoft.com/office/drawing/2014/main" id="{F8AF45CF-EDC7-4926-B9AE-0C3281756219}"/>
+              </a:ext>
+            </a:extLst>
+          </p:cNvPr>
+          <p:cNvSpPr>
+            <a:spLocks xmlns:a="http://schemas.openxmlformats.org/drawingml/2006/main" noGrp="1"/>
+          </p:cNvSpPr>
+          <p:nvPr/>
+        </p:nvSpPr>
+        <p:spPr>
+          <a:xfrm xmlns:a="http://schemas.openxmlformats.org/drawingml/2006/main">
+            <a:off x="9906000" y="552450"/>
+            <a:ext cx="1600200" cy="228600"/>
+          </a:xfrm>
+          <a:prstGeom xmlns:a="http://schemas.openxmlformats.org/drawingml/2006/main" prst="rect">
+            <a:avLst/>
+          </a:prstGeom>
+          <a:noFill xmlns:a="http://schemas.openxmlformats.org/drawingml/2006/main"/>
+          <a:ln xmlns:a="http://schemas.openxmlformats.org/drawingml/2006/main" w="0">
+            <a:noFill/>
+            <a:prstDash val="solid"/>
+          </a:ln>
+        </p:spPr>
+        <p:txBody>
+          <a:bodyPr xmlns:a="http://schemas.openxmlformats.org/drawingml/2006/main">
+            <a:noAutofit/>
+          </a:bodyPr>
+          <a:lstStyle xmlns:a="http://schemas.openxmlformats.org/drawingml/2006/main">
+            <a:defPPr>
+              <a:defRPr sz="975" b="0">
+                <a:solidFill>
+                  <a:srgbClr val="8A94A3"/>
+                </a:solidFill>
+                <a:latin typeface="Arial"/>
+                <a:ea typeface="Arial"/>
+                <a:cs typeface="Arial"/>
+              </a:defRPr>
+            </a:defPPr>
+          </a:lstStyle>
+          <a:p xmlns:a="http://schemas.openxmlformats.org/drawingml/2006/main">
+            <a:pPr>
+              <a:defRPr sz="975" b="0">
+                <a:solidFill>
+                  <a:srgbClr val="8A94A3"/>
+                </a:solidFill>
+                <a:latin typeface="Arial"/>
+                <a:ea typeface="Arial"/>
+                <a:cs typeface="Arial"/>
+              </a:defRPr>
+            </a:pPr>
+            <a:r>
+              <a:rPr sz="975" b="0">
+                <a:solidFill>
+                  <a:srgbClr val="8A94A3"/>
+                </a:solidFill>
+                <a:latin typeface="Arial"/>
+                <a:ea typeface="Arial"/>
+                <a:cs typeface="Arial"/>
+              </a:rPr>
+              <a:t>10 / 10</a:t>
+            </a:r>
+          </a:p>
+        </p:txBody>
+      </p:sp>
+      <p:sp>
+        <p:nvSpPr>
+          <p:cNvPr id="2" name="slide-title">
+            <a:extLst xmlns:a="http://schemas.openxmlformats.org/drawingml/2006/main">
+              <a:ext uri="{FF2B5EF4-FFF2-40B4-BE49-F238E27FC236}">
+                <a16:creationId xmlns:a16="http://schemas.microsoft.com/office/drawing/2014/main" id="{2BF4B391-A78D-41E4-A0DB-F98D891239A5}"/>
               </a:ext>
             </a:extLst>
           </p:cNvPr>
@@ -3766,10 +3859,10 @@
       </p:sp>
       <p:sp>
         <p:nvSpPr>
-          <p:cNvPr id="2" name="slide-lead">
+          <p:cNvPr id="3" name="slide-lead">
             <a:extLst xmlns:a="http://schemas.openxmlformats.org/drawingml/2006/main">
               <a:ext uri="{FF2B5EF4-FFF2-40B4-BE49-F238E27FC236}">
-                <a16:creationId xmlns:a16="http://schemas.microsoft.com/office/drawing/2014/main" id="{9EAD16F7-0BBA-474B-9938-AD2D017AE82F}"/>
+                <a16:creationId xmlns:a16="http://schemas.microsoft.com/office/drawing/2014/main" id="{50B1C235-FD64-45D3-9A98-A4BA5D8337BB}"/>
               </a:ext>
             </a:extLst>
           </p:cNvPr>
@@ -3835,10 +3928,10 @@
       </p:sp>
       <p:sp>
         <p:nvSpPr>
-          <p:cNvPr id="3" name="title-rule">
+          <p:cNvPr id="4" name="title-rule">
             <a:extLst xmlns:a="http://schemas.openxmlformats.org/drawingml/2006/main">
               <a:ext uri="{FF2B5EF4-FFF2-40B4-BE49-F238E27FC236}">
-                <a16:creationId xmlns:a16="http://schemas.microsoft.com/office/drawing/2014/main" id="{D285418A-22D7-411D-BCF8-F6C46E157555}"/>
+                <a16:creationId xmlns:a16="http://schemas.microsoft.com/office/drawing/2014/main" id="{EB323F36-9912-4A32-9227-AA40A9CC7D81}"/>
               </a:ext>
             </a:extLst>
           </p:cNvPr>
@@ -3866,10 +3959,10 @@
       </p:sp>
       <p:sp>
         <p:nvSpPr>
-          <p:cNvPr id="4" name="">
+          <p:cNvPr id="5" name="">
             <a:extLst xmlns:a="http://schemas.openxmlformats.org/drawingml/2006/main">
               <a:ext uri="{FF2B5EF4-FFF2-40B4-BE49-F238E27FC236}">
-                <a16:creationId xmlns:a16="http://schemas.microsoft.com/office/drawing/2014/main" id="{8738FD18-F3E5-4B18-9D5E-679078B0B2C1}"/>
+                <a16:creationId xmlns:a16="http://schemas.microsoft.com/office/drawing/2014/main" id="{6E75C2A9-200D-4D84-8EF5-6AEABFD4412B}"/>
               </a:ext>
             </a:extLst>
           </p:cNvPr>
@@ -3935,10 +4028,10 @@
       </p:sp>
       <p:sp>
         <p:nvSpPr>
-          <p:cNvPr id="5" name="">
+          <p:cNvPr id="6" name="">
             <a:extLst xmlns:a="http://schemas.openxmlformats.org/drawingml/2006/main">
               <a:ext uri="{FF2B5EF4-FFF2-40B4-BE49-F238E27FC236}">
-                <a16:creationId xmlns:a16="http://schemas.microsoft.com/office/drawing/2014/main" id="{9CFB7D00-7236-422E-9E6A-D31211A75ED3}"/>
+                <a16:creationId xmlns:a16="http://schemas.microsoft.com/office/drawing/2014/main" id="{000F5FC2-F6FB-4D25-826A-578868629B0B}"/>
               </a:ext>
             </a:extLst>
           </p:cNvPr>
@@ -4089,10 +4182,10 @@
       </p:sp>
       <p:sp>
         <p:nvSpPr>
-          <p:cNvPr id="6" name="">
+          <p:cNvPr id="7" name="">
             <a:extLst xmlns:a="http://schemas.openxmlformats.org/drawingml/2006/main">
               <a:ext uri="{FF2B5EF4-FFF2-40B4-BE49-F238E27FC236}">
-                <a16:creationId xmlns:a16="http://schemas.microsoft.com/office/drawing/2014/main" id="{C1E6D0D4-AF7E-4141-B6AF-5DFBACBDD992}"/>
+                <a16:creationId xmlns:a16="http://schemas.microsoft.com/office/drawing/2014/main" id="{8558097C-894A-4FF6-B051-E73CF0CC9208}"/>
               </a:ext>
             </a:extLst>
           </p:cNvPr>
@@ -4158,10 +4251,10 @@
       </p:sp>
       <p:sp>
         <p:nvSpPr>
-          <p:cNvPr id="7" name="">
+          <p:cNvPr id="8" name="">
             <a:extLst xmlns:a="http://schemas.openxmlformats.org/drawingml/2006/main">
               <a:ext uri="{FF2B5EF4-FFF2-40B4-BE49-F238E27FC236}">
-                <a16:creationId xmlns:a16="http://schemas.microsoft.com/office/drawing/2014/main" id="{B52F5FF0-BD49-4B6B-B16D-C349AE52EFC1}"/>
+                <a16:creationId xmlns:a16="http://schemas.microsoft.com/office/drawing/2014/main" id="{73ECEDF0-D229-4090-8EF4-AA225934C51B}"/>
               </a:ext>
             </a:extLst>
           </p:cNvPr>
@@ -4313,7 +4406,7 @@
     </p:spTree>
     <p:extLst>
       <p:ext uri="{BB962C8B-B14F-4D97-AF65-F5344CB8AC3E}">
-        <p14:creationId xmlns:p14="http://schemas.microsoft.com/office/powerpoint/2010/main" val="57701514"/>
+        <p14:creationId xmlns:p14="http://schemas.microsoft.com/office/powerpoint/2010/main" val="274963172"/>
       </p:ext>
     </p:extLst>
   </p:cSld>
@@ -4341,10 +4434,79 @@
       </p:grpSpPr>
       <p:sp>
         <p:nvSpPr>
-          <p:cNvPr id="6" name="slide-title">
+          <p:cNvPr id="7" name="">
             <a:extLst xmlns:a="http://schemas.openxmlformats.org/drawingml/2006/main">
               <a:ext uri="{FF2B5EF4-FFF2-40B4-BE49-F238E27FC236}">
-                <a16:creationId xmlns:a16="http://schemas.microsoft.com/office/drawing/2014/main" id="{2882AC03-698C-4472-8D93-5D600C3B2B5D}"/>
+                <a16:creationId xmlns:a16="http://schemas.microsoft.com/office/drawing/2014/main" id="{63D70C23-E566-4375-B664-6286F851F721}"/>
+              </a:ext>
+            </a:extLst>
+          </p:cNvPr>
+          <p:cNvSpPr>
+            <a:spLocks xmlns:a="http://schemas.openxmlformats.org/drawingml/2006/main" noGrp="1"/>
+          </p:cNvSpPr>
+          <p:nvPr/>
+        </p:nvSpPr>
+        <p:spPr>
+          <a:xfrm xmlns:a="http://schemas.openxmlformats.org/drawingml/2006/main">
+            <a:off x="9906000" y="552450"/>
+            <a:ext cx="1600200" cy="228600"/>
+          </a:xfrm>
+          <a:prstGeom xmlns:a="http://schemas.openxmlformats.org/drawingml/2006/main" prst="rect">
+            <a:avLst/>
+          </a:prstGeom>
+          <a:noFill xmlns:a="http://schemas.openxmlformats.org/drawingml/2006/main"/>
+          <a:ln xmlns:a="http://schemas.openxmlformats.org/drawingml/2006/main" w="0">
+            <a:noFill/>
+            <a:prstDash val="solid"/>
+          </a:ln>
+        </p:spPr>
+        <p:txBody>
+          <a:bodyPr xmlns:a="http://schemas.openxmlformats.org/drawingml/2006/main">
+            <a:noAutofit/>
+          </a:bodyPr>
+          <a:lstStyle xmlns:a="http://schemas.openxmlformats.org/drawingml/2006/main">
+            <a:defPPr>
+              <a:defRPr sz="975" b="0">
+                <a:solidFill>
+                  <a:srgbClr val="8A94A3"/>
+                </a:solidFill>
+                <a:latin typeface="Arial"/>
+                <a:ea typeface="Arial"/>
+                <a:cs typeface="Arial"/>
+              </a:defRPr>
+            </a:defPPr>
+          </a:lstStyle>
+          <a:p xmlns:a="http://schemas.openxmlformats.org/drawingml/2006/main">
+            <a:pPr>
+              <a:defRPr sz="975" b="0">
+                <a:solidFill>
+                  <a:srgbClr val="8A94A3"/>
+                </a:solidFill>
+                <a:latin typeface="Arial"/>
+                <a:ea typeface="Arial"/>
+                <a:cs typeface="Arial"/>
+              </a:defRPr>
+            </a:pPr>
+            <a:r>
+              <a:rPr sz="975" b="0">
+                <a:solidFill>
+                  <a:srgbClr val="8A94A3"/>
+                </a:solidFill>
+                <a:latin typeface="Arial"/>
+                <a:ea typeface="Arial"/>
+                <a:cs typeface="Arial"/>
+              </a:rPr>
+              <a:t>2 / 10</a:t>
+            </a:r>
+          </a:p>
+        </p:txBody>
+      </p:sp>
+      <p:sp>
+        <p:nvSpPr>
+          <p:cNvPr id="2" name="slide-title">
+            <a:extLst xmlns:a="http://schemas.openxmlformats.org/drawingml/2006/main">
+              <a:ext uri="{FF2B5EF4-FFF2-40B4-BE49-F238E27FC236}">
+                <a16:creationId xmlns:a16="http://schemas.microsoft.com/office/drawing/2014/main" id="{9E25F9E3-2EDF-4D51-B038-48DAA0957551}"/>
               </a:ext>
             </a:extLst>
           </p:cNvPr>
@@ -4410,10 +4572,10 @@
       </p:sp>
       <p:sp>
         <p:nvSpPr>
-          <p:cNvPr id="2" name="slide-lead">
+          <p:cNvPr id="3" name="slide-lead">
             <a:extLst xmlns:a="http://schemas.openxmlformats.org/drawingml/2006/main">
               <a:ext uri="{FF2B5EF4-FFF2-40B4-BE49-F238E27FC236}">
-                <a16:creationId xmlns:a16="http://schemas.microsoft.com/office/drawing/2014/main" id="{CE6CB539-B0F3-4315-A8CA-6F5EE1B5C946}"/>
+                <a16:creationId xmlns:a16="http://schemas.microsoft.com/office/drawing/2014/main" id="{5B01DF31-4490-4071-8D2C-B4EBFD68D626}"/>
               </a:ext>
             </a:extLst>
           </p:cNvPr>
@@ -4479,10 +4641,10 @@
       </p:sp>
       <p:sp>
         <p:nvSpPr>
-          <p:cNvPr id="3" name="title-rule">
+          <p:cNvPr id="4" name="title-rule">
             <a:extLst xmlns:a="http://schemas.openxmlformats.org/drawingml/2006/main">
               <a:ext uri="{FF2B5EF4-FFF2-40B4-BE49-F238E27FC236}">
-                <a16:creationId xmlns:a16="http://schemas.microsoft.com/office/drawing/2014/main" id="{B596F400-1A12-4ED6-8D0D-8FEBBEA7FFF1}"/>
+                <a16:creationId xmlns:a16="http://schemas.microsoft.com/office/drawing/2014/main" id="{ACD38377-596C-432D-A905-5B93B3278BC7}"/>
               </a:ext>
             </a:extLst>
           </p:cNvPr>
@@ -4510,10 +4672,10 @@
       </p:sp>
       <p:sp>
         <p:nvSpPr>
-          <p:cNvPr id="4" name="">
+          <p:cNvPr id="5" name="">
             <a:extLst xmlns:a="http://schemas.openxmlformats.org/drawingml/2006/main">
               <a:ext uri="{FF2B5EF4-FFF2-40B4-BE49-F238E27FC236}">
-                <a16:creationId xmlns:a16="http://schemas.microsoft.com/office/drawing/2014/main" id="{7D85989B-8D50-4804-B073-CBC4C44A457D}"/>
+                <a16:creationId xmlns:a16="http://schemas.microsoft.com/office/drawing/2014/main" id="{3546BCD1-5B5C-4D5C-89DB-78249666581D}"/>
               </a:ext>
             </a:extLst>
           </p:cNvPr>
@@ -4664,10 +4826,10 @@
       </p:sp>
       <p:sp>
         <p:nvSpPr>
-          <p:cNvPr id="5" name="">
+          <p:cNvPr id="6" name="">
             <a:extLst xmlns:a="http://schemas.openxmlformats.org/drawingml/2006/main">
               <a:ext uri="{FF2B5EF4-FFF2-40B4-BE49-F238E27FC236}">
-                <a16:creationId xmlns:a16="http://schemas.microsoft.com/office/drawing/2014/main" id="{9AE03512-EC11-4C07-BD87-0455613D3EBD}"/>
+                <a16:creationId xmlns:a16="http://schemas.microsoft.com/office/drawing/2014/main" id="{F39F343D-DB46-4530-B879-5D447E75EAAD}"/>
               </a:ext>
             </a:extLst>
           </p:cNvPr>
@@ -4734,7 +4896,7 @@
     </p:spTree>
     <p:extLst>
       <p:ext uri="{BB962C8B-B14F-4D97-AF65-F5344CB8AC3E}">
-        <p14:creationId xmlns:p14="http://schemas.microsoft.com/office/powerpoint/2010/main" val="1671226012"/>
+        <p14:creationId xmlns:p14="http://schemas.microsoft.com/office/powerpoint/2010/main" val="771386058"/>
       </p:ext>
     </p:extLst>
   </p:cSld>
@@ -4762,10 +4924,79 @@
       </p:grpSpPr>
       <p:sp>
         <p:nvSpPr>
-          <p:cNvPr id="6" name="slide-title">
+          <p:cNvPr id="7" name="">
             <a:extLst xmlns:a="http://schemas.openxmlformats.org/drawingml/2006/main">
               <a:ext uri="{FF2B5EF4-FFF2-40B4-BE49-F238E27FC236}">
-                <a16:creationId xmlns:a16="http://schemas.microsoft.com/office/drawing/2014/main" id="{89B539FD-7431-4107-BB92-624EEE617605}"/>
+                <a16:creationId xmlns:a16="http://schemas.microsoft.com/office/drawing/2014/main" id="{9DF8445D-6FAA-451F-9782-742EC9904EFD}"/>
+              </a:ext>
+            </a:extLst>
+          </p:cNvPr>
+          <p:cNvSpPr>
+            <a:spLocks xmlns:a="http://schemas.openxmlformats.org/drawingml/2006/main" noGrp="1"/>
+          </p:cNvSpPr>
+          <p:nvPr/>
+        </p:nvSpPr>
+        <p:spPr>
+          <a:xfrm xmlns:a="http://schemas.openxmlformats.org/drawingml/2006/main">
+            <a:off x="9906000" y="552450"/>
+            <a:ext cx="1600200" cy="228600"/>
+          </a:xfrm>
+          <a:prstGeom xmlns:a="http://schemas.openxmlformats.org/drawingml/2006/main" prst="rect">
+            <a:avLst/>
+          </a:prstGeom>
+          <a:noFill xmlns:a="http://schemas.openxmlformats.org/drawingml/2006/main"/>
+          <a:ln xmlns:a="http://schemas.openxmlformats.org/drawingml/2006/main" w="0">
+            <a:noFill/>
+            <a:prstDash val="solid"/>
+          </a:ln>
+        </p:spPr>
+        <p:txBody>
+          <a:bodyPr xmlns:a="http://schemas.openxmlformats.org/drawingml/2006/main">
+            <a:noAutofit/>
+          </a:bodyPr>
+          <a:lstStyle xmlns:a="http://schemas.openxmlformats.org/drawingml/2006/main">
+            <a:defPPr>
+              <a:defRPr sz="975" b="0">
+                <a:solidFill>
+                  <a:srgbClr val="8A94A3"/>
+                </a:solidFill>
+                <a:latin typeface="Arial"/>
+                <a:ea typeface="Arial"/>
+                <a:cs typeface="Arial"/>
+              </a:defRPr>
+            </a:defPPr>
+          </a:lstStyle>
+          <a:p xmlns:a="http://schemas.openxmlformats.org/drawingml/2006/main">
+            <a:pPr>
+              <a:defRPr sz="975" b="0">
+                <a:solidFill>
+                  <a:srgbClr val="8A94A3"/>
+                </a:solidFill>
+                <a:latin typeface="Arial"/>
+                <a:ea typeface="Arial"/>
+                <a:cs typeface="Arial"/>
+              </a:defRPr>
+            </a:pPr>
+            <a:r>
+              <a:rPr sz="975" b="0">
+                <a:solidFill>
+                  <a:srgbClr val="8A94A3"/>
+                </a:solidFill>
+                <a:latin typeface="Arial"/>
+                <a:ea typeface="Arial"/>
+                <a:cs typeface="Arial"/>
+              </a:rPr>
+              <a:t>3 / 10</a:t>
+            </a:r>
+          </a:p>
+        </p:txBody>
+      </p:sp>
+      <p:sp>
+        <p:nvSpPr>
+          <p:cNvPr id="2" name="slide-title">
+            <a:extLst xmlns:a="http://schemas.openxmlformats.org/drawingml/2006/main">
+              <a:ext uri="{FF2B5EF4-FFF2-40B4-BE49-F238E27FC236}">
+                <a16:creationId xmlns:a16="http://schemas.microsoft.com/office/drawing/2014/main" id="{E511E956-74AF-4CDE-9C2F-FDC489DB4B88}"/>
               </a:ext>
             </a:extLst>
           </p:cNvPr>
@@ -4831,10 +5062,10 @@
       </p:sp>
       <p:sp>
         <p:nvSpPr>
-          <p:cNvPr id="2" name="slide-lead">
+          <p:cNvPr id="3" name="slide-lead">
             <a:extLst xmlns:a="http://schemas.openxmlformats.org/drawingml/2006/main">
               <a:ext uri="{FF2B5EF4-FFF2-40B4-BE49-F238E27FC236}">
-                <a16:creationId xmlns:a16="http://schemas.microsoft.com/office/drawing/2014/main" id="{CD6605DF-128D-49E8-88F3-D0A582778D0F}"/>
+                <a16:creationId xmlns:a16="http://schemas.microsoft.com/office/drawing/2014/main" id="{CB8BC447-188B-498F-BB4E-A915A1948468}"/>
               </a:ext>
             </a:extLst>
           </p:cNvPr>
@@ -4900,10 +5131,10 @@
       </p:sp>
       <p:sp>
         <p:nvSpPr>
-          <p:cNvPr id="3" name="title-rule">
+          <p:cNvPr id="4" name="title-rule">
             <a:extLst xmlns:a="http://schemas.openxmlformats.org/drawingml/2006/main">
               <a:ext uri="{FF2B5EF4-FFF2-40B4-BE49-F238E27FC236}">
-                <a16:creationId xmlns:a16="http://schemas.microsoft.com/office/drawing/2014/main" id="{AB3E182A-CDD8-4396-8B47-EB897C79AFC2}"/>
+                <a16:creationId xmlns:a16="http://schemas.microsoft.com/office/drawing/2014/main" id="{34FCDC96-0E22-4954-9D24-00F729E82C40}"/>
               </a:ext>
             </a:extLst>
           </p:cNvPr>
@@ -4931,10 +5162,10 @@
       </p:sp>
       <p:graphicFrame>
         <p:nvGraphicFramePr>
-          <p:cNvPr id="4" name="">
+          <p:cNvPr id="5" name="">
             <a:extLst xmlns:a="http://schemas.openxmlformats.org/drawingml/2006/main">
               <a:ext uri="{FF2B5EF4-FFF2-40B4-BE49-F238E27FC236}">
-                <a16:creationId xmlns:a16="http://schemas.microsoft.com/office/drawing/2014/main" id="{75EA5F0A-CDEC-44E8-87C5-BD460CC80888}"/>
+                <a16:creationId xmlns:a16="http://schemas.microsoft.com/office/drawing/2014/main" id="{561290B9-0CD4-4AB4-B52D-5F443F706E4A}"/>
               </a:ext>
             </a:extLst>
           </p:cNvPr>
@@ -5448,10 +5679,10 @@
       </p:graphicFrame>
       <p:sp>
         <p:nvSpPr>
-          <p:cNvPr id="5" name="">
+          <p:cNvPr id="6" name="">
             <a:extLst xmlns:a="http://schemas.openxmlformats.org/drawingml/2006/main">
               <a:ext uri="{FF2B5EF4-FFF2-40B4-BE49-F238E27FC236}">
-                <a16:creationId xmlns:a16="http://schemas.microsoft.com/office/drawing/2014/main" id="{BFF87692-A083-4727-9349-A09FA3A57CF4}"/>
+                <a16:creationId xmlns:a16="http://schemas.microsoft.com/office/drawing/2014/main" id="{ED5B225C-46B1-407A-87A7-26F3718DD430}"/>
               </a:ext>
             </a:extLst>
           </p:cNvPr>
@@ -5518,7 +5749,7 @@
     </p:spTree>
     <p:extLst>
       <p:ext uri="{BB962C8B-B14F-4D97-AF65-F5344CB8AC3E}">
-        <p14:creationId xmlns:p14="http://schemas.microsoft.com/office/powerpoint/2010/main" val="1867080313"/>
+        <p14:creationId xmlns:p14="http://schemas.microsoft.com/office/powerpoint/2010/main" val="620210820"/>
       </p:ext>
     </p:extLst>
   </p:cSld>
@@ -5546,10 +5777,79 @@
       </p:grpSpPr>
       <p:sp>
         <p:nvSpPr>
-          <p:cNvPr id="28" name="slide-title">
+          <p:cNvPr id="29" name="">
             <a:extLst xmlns:a="http://schemas.openxmlformats.org/drawingml/2006/main">
               <a:ext uri="{FF2B5EF4-FFF2-40B4-BE49-F238E27FC236}">
-                <a16:creationId xmlns:a16="http://schemas.microsoft.com/office/drawing/2014/main" id="{77B17EB2-686C-4965-BDF3-45053624BD11}"/>
+                <a16:creationId xmlns:a16="http://schemas.microsoft.com/office/drawing/2014/main" id="{DC6E6878-76FD-4449-8972-CABA218221CF}"/>
+              </a:ext>
+            </a:extLst>
+          </p:cNvPr>
+          <p:cNvSpPr>
+            <a:spLocks xmlns:a="http://schemas.openxmlformats.org/drawingml/2006/main" noGrp="1"/>
+          </p:cNvSpPr>
+          <p:nvPr/>
+        </p:nvSpPr>
+        <p:spPr>
+          <a:xfrm xmlns:a="http://schemas.openxmlformats.org/drawingml/2006/main">
+            <a:off x="9906000" y="552450"/>
+            <a:ext cx="1600200" cy="228600"/>
+          </a:xfrm>
+          <a:prstGeom xmlns:a="http://schemas.openxmlformats.org/drawingml/2006/main" prst="rect">
+            <a:avLst/>
+          </a:prstGeom>
+          <a:noFill xmlns:a="http://schemas.openxmlformats.org/drawingml/2006/main"/>
+          <a:ln xmlns:a="http://schemas.openxmlformats.org/drawingml/2006/main" w="0">
+            <a:noFill/>
+            <a:prstDash val="solid"/>
+          </a:ln>
+        </p:spPr>
+        <p:txBody>
+          <a:bodyPr xmlns:a="http://schemas.openxmlformats.org/drawingml/2006/main">
+            <a:noAutofit/>
+          </a:bodyPr>
+          <a:lstStyle xmlns:a="http://schemas.openxmlformats.org/drawingml/2006/main">
+            <a:defPPr>
+              <a:defRPr sz="975" b="0">
+                <a:solidFill>
+                  <a:srgbClr val="8A94A3"/>
+                </a:solidFill>
+                <a:latin typeface="Arial"/>
+                <a:ea typeface="Arial"/>
+                <a:cs typeface="Arial"/>
+              </a:defRPr>
+            </a:defPPr>
+          </a:lstStyle>
+          <a:p xmlns:a="http://schemas.openxmlformats.org/drawingml/2006/main">
+            <a:pPr>
+              <a:defRPr sz="975" b="0">
+                <a:solidFill>
+                  <a:srgbClr val="8A94A3"/>
+                </a:solidFill>
+                <a:latin typeface="Arial"/>
+                <a:ea typeface="Arial"/>
+                <a:cs typeface="Arial"/>
+              </a:defRPr>
+            </a:pPr>
+            <a:r>
+              <a:rPr sz="975" b="0">
+                <a:solidFill>
+                  <a:srgbClr val="8A94A3"/>
+                </a:solidFill>
+                <a:latin typeface="Arial"/>
+                <a:ea typeface="Arial"/>
+                <a:cs typeface="Arial"/>
+              </a:rPr>
+              <a:t>4 / 10</a:t>
+            </a:r>
+          </a:p>
+        </p:txBody>
+      </p:sp>
+      <p:sp>
+        <p:nvSpPr>
+          <p:cNvPr id="2" name="slide-title">
+            <a:extLst xmlns:a="http://schemas.openxmlformats.org/drawingml/2006/main">
+              <a:ext uri="{FF2B5EF4-FFF2-40B4-BE49-F238E27FC236}">
+                <a16:creationId xmlns:a16="http://schemas.microsoft.com/office/drawing/2014/main" id="{801E302E-187A-447A-86CD-1B1A8F453873}"/>
               </a:ext>
             </a:extLst>
           </p:cNvPr>
@@ -5615,10 +5915,10 @@
       </p:sp>
       <p:sp>
         <p:nvSpPr>
-          <p:cNvPr id="2" name="slide-lead">
+          <p:cNvPr id="3" name="slide-lead">
             <a:extLst xmlns:a="http://schemas.openxmlformats.org/drawingml/2006/main">
               <a:ext uri="{FF2B5EF4-FFF2-40B4-BE49-F238E27FC236}">
-                <a16:creationId xmlns:a16="http://schemas.microsoft.com/office/drawing/2014/main" id="{B7DD30C3-6D61-4AB3-A058-AD336764662E}"/>
+                <a16:creationId xmlns:a16="http://schemas.microsoft.com/office/drawing/2014/main" id="{8C07C81E-D83A-4032-90DE-1CC35CFBD585}"/>
               </a:ext>
             </a:extLst>
           </p:cNvPr>
@@ -5684,10 +5984,10 @@
       </p:sp>
       <p:sp>
         <p:nvSpPr>
-          <p:cNvPr id="3" name="title-rule">
+          <p:cNvPr id="4" name="title-rule">
             <a:extLst xmlns:a="http://schemas.openxmlformats.org/drawingml/2006/main">
               <a:ext uri="{FF2B5EF4-FFF2-40B4-BE49-F238E27FC236}">
-                <a16:creationId xmlns:a16="http://schemas.microsoft.com/office/drawing/2014/main" id="{EB42269D-9FB1-4BA9-BC3D-93AF8AD5C064}"/>
+                <a16:creationId xmlns:a16="http://schemas.microsoft.com/office/drawing/2014/main" id="{2CF428CA-86DC-4437-889C-9B51091408B6}"/>
               </a:ext>
             </a:extLst>
           </p:cNvPr>
@@ -5715,10 +6015,10 @@
       </p:sp>
       <p:sp>
         <p:nvSpPr>
-          <p:cNvPr id="4" name="flow-Donation registered">
+          <p:cNvPr id="5" name="flow-Donation registered">
             <a:extLst xmlns:a="http://schemas.openxmlformats.org/drawingml/2006/main">
               <a:ext uri="{FF2B5EF4-FFF2-40B4-BE49-F238E27FC236}">
-                <a16:creationId xmlns:a16="http://schemas.microsoft.com/office/drawing/2014/main" id="{2E13E6CF-3809-42F3-B87D-66B9F1742892}"/>
+                <a16:creationId xmlns:a16="http://schemas.microsoft.com/office/drawing/2014/main" id="{A77193FC-A53F-4FB3-9BE1-2B556B51A6C6}"/>
               </a:ext>
             </a:extLst>
           </p:cNvPr>
@@ -5750,10 +6050,10 @@
       </p:sp>
       <p:sp>
         <p:nvSpPr>
-          <p:cNvPr id="5" name="">
+          <p:cNvPr id="6" name="">
             <a:extLst xmlns:a="http://schemas.openxmlformats.org/drawingml/2006/main">
               <a:ext uri="{FF2B5EF4-FFF2-40B4-BE49-F238E27FC236}">
-                <a16:creationId xmlns:a16="http://schemas.microsoft.com/office/drawing/2014/main" id="{E3AC78C6-6A9A-45D1-9E8F-DAB35DB5376E}"/>
+                <a16:creationId xmlns:a16="http://schemas.microsoft.com/office/drawing/2014/main" id="{9A3CCF73-472F-42E9-AAA8-AC802C331ABA}"/>
               </a:ext>
             </a:extLst>
           </p:cNvPr>
@@ -5819,10 +6119,10 @@
       </p:sp>
       <p:sp>
         <p:nvSpPr>
-          <p:cNvPr id="6" name="">
+          <p:cNvPr id="7" name="">
             <a:extLst xmlns:a="http://schemas.openxmlformats.org/drawingml/2006/main">
               <a:ext uri="{FF2B5EF4-FFF2-40B4-BE49-F238E27FC236}">
-                <a16:creationId xmlns:a16="http://schemas.microsoft.com/office/drawing/2014/main" id="{28158BB2-8F5F-4738-A105-539CFB3614BE}"/>
+                <a16:creationId xmlns:a16="http://schemas.microsoft.com/office/drawing/2014/main" id="{ECDC5B81-159B-48D0-A05C-CE31581959A0}"/>
               </a:ext>
             </a:extLst>
           </p:cNvPr>
@@ -5888,10 +6188,10 @@
       </p:sp>
       <p:sp>
         <p:nvSpPr>
-          <p:cNvPr id="7" name="">
+          <p:cNvPr id="8" name="">
             <a:extLst xmlns:a="http://schemas.openxmlformats.org/drawingml/2006/main">
               <a:ext uri="{FF2B5EF4-FFF2-40B4-BE49-F238E27FC236}">
-                <a16:creationId xmlns:a16="http://schemas.microsoft.com/office/drawing/2014/main" id="{9CA3B303-F36F-401A-B279-CC1ED34271A6}"/>
+                <a16:creationId xmlns:a16="http://schemas.microsoft.com/office/drawing/2014/main" id="{B7E7D6C0-7E71-4F1F-B0FF-3CEDD736FEDF}"/>
               </a:ext>
             </a:extLst>
           </p:cNvPr>
@@ -5919,10 +6219,10 @@
       </p:sp>
       <p:sp>
         <p:nvSpPr>
-          <p:cNvPr id="8" name="flow-Engine ranks recipients">
+          <p:cNvPr id="9" name="flow-Engine ranks recipients">
             <a:extLst xmlns:a="http://schemas.openxmlformats.org/drawingml/2006/main">
               <a:ext uri="{FF2B5EF4-FFF2-40B4-BE49-F238E27FC236}">
-                <a16:creationId xmlns:a16="http://schemas.microsoft.com/office/drawing/2014/main" id="{76FC2C93-2DA2-4B72-9D86-26B480358AB4}"/>
+                <a16:creationId xmlns:a16="http://schemas.microsoft.com/office/drawing/2014/main" id="{20CDD4A0-589F-40EE-85DC-F8F8D614074B}"/>
               </a:ext>
             </a:extLst>
           </p:cNvPr>
@@ -5954,10 +6254,10 @@
       </p:sp>
       <p:sp>
         <p:nvSpPr>
-          <p:cNvPr id="9" name="">
+          <p:cNvPr id="10" name="">
             <a:extLst xmlns:a="http://schemas.openxmlformats.org/drawingml/2006/main">
               <a:ext uri="{FF2B5EF4-FFF2-40B4-BE49-F238E27FC236}">
-                <a16:creationId xmlns:a16="http://schemas.microsoft.com/office/drawing/2014/main" id="{38110290-AA22-441D-A1AD-F91B415F3862}"/>
+                <a16:creationId xmlns:a16="http://schemas.microsoft.com/office/drawing/2014/main" id="{B3EFB688-372C-4935-8CC3-7587248D529E}"/>
               </a:ext>
             </a:extLst>
           </p:cNvPr>
@@ -6023,10 +6323,10 @@
       </p:sp>
       <p:sp>
         <p:nvSpPr>
-          <p:cNvPr id="10" name="">
+          <p:cNvPr id="11" name="">
             <a:extLst xmlns:a="http://schemas.openxmlformats.org/drawingml/2006/main">
               <a:ext uri="{FF2B5EF4-FFF2-40B4-BE49-F238E27FC236}">
-                <a16:creationId xmlns:a16="http://schemas.microsoft.com/office/drawing/2014/main" id="{3AF2E221-9F4F-4F63-A2F5-FF027A6D04C7}"/>
+                <a16:creationId xmlns:a16="http://schemas.microsoft.com/office/drawing/2014/main" id="{FFBE704D-5F84-4230-815E-53032C3C6FDD}"/>
               </a:ext>
             </a:extLst>
           </p:cNvPr>
@@ -6092,10 +6392,10 @@
       </p:sp>
       <p:sp>
         <p:nvSpPr>
-          <p:cNvPr id="11" name="">
+          <p:cNvPr id="12" name="">
             <a:extLst xmlns:a="http://schemas.openxmlformats.org/drawingml/2006/main">
               <a:ext uri="{FF2B5EF4-FFF2-40B4-BE49-F238E27FC236}">
-                <a16:creationId xmlns:a16="http://schemas.microsoft.com/office/drawing/2014/main" id="{BBD0050E-B788-4379-B455-0532795A5995}"/>
+                <a16:creationId xmlns:a16="http://schemas.microsoft.com/office/drawing/2014/main" id="{3769E8A7-A2EB-42EB-9524-639FB23791B2}"/>
               </a:ext>
             </a:extLst>
           </p:cNvPr>
@@ -6123,10 +6423,10 @@
       </p:sp>
       <p:sp>
         <p:nvSpPr>
-          <p:cNvPr id="12" name="flow-Recipient accepts">
+          <p:cNvPr id="13" name="flow-Recipient accepts">
             <a:extLst xmlns:a="http://schemas.openxmlformats.org/drawingml/2006/main">
               <a:ext uri="{FF2B5EF4-FFF2-40B4-BE49-F238E27FC236}">
-                <a16:creationId xmlns:a16="http://schemas.microsoft.com/office/drawing/2014/main" id="{1717B9D7-F36C-49D6-BF99-79FB3EA3DA70}"/>
+                <a16:creationId xmlns:a16="http://schemas.microsoft.com/office/drawing/2014/main" id="{FF0735AD-5B04-4712-8ECF-F3F90A7B54F1}"/>
               </a:ext>
             </a:extLst>
           </p:cNvPr>
@@ -6158,10 +6458,10 @@
       </p:sp>
       <p:sp>
         <p:nvSpPr>
-          <p:cNvPr id="13" name="">
+          <p:cNvPr id="14" name="">
             <a:extLst xmlns:a="http://schemas.openxmlformats.org/drawingml/2006/main">
               <a:ext uri="{FF2B5EF4-FFF2-40B4-BE49-F238E27FC236}">
-                <a16:creationId xmlns:a16="http://schemas.microsoft.com/office/drawing/2014/main" id="{E1BF04A8-0394-4627-9326-631738EE14E9}"/>
+                <a16:creationId xmlns:a16="http://schemas.microsoft.com/office/drawing/2014/main" id="{76C3600D-D088-404A-8E4D-66C1A9A65283}"/>
               </a:ext>
             </a:extLst>
           </p:cNvPr>
@@ -6227,10 +6527,10 @@
       </p:sp>
       <p:sp>
         <p:nvSpPr>
-          <p:cNvPr id="14" name="">
+          <p:cNvPr id="15" name="">
             <a:extLst xmlns:a="http://schemas.openxmlformats.org/drawingml/2006/main">
               <a:ext uri="{FF2B5EF4-FFF2-40B4-BE49-F238E27FC236}">
-                <a16:creationId xmlns:a16="http://schemas.microsoft.com/office/drawing/2014/main" id="{BE94ADEC-A521-4FAF-A7D0-8C4810D1A533}"/>
+                <a16:creationId xmlns:a16="http://schemas.microsoft.com/office/drawing/2014/main" id="{C28CD99B-63A6-4A7C-AEE4-8F0678F1B675}"/>
               </a:ext>
             </a:extLst>
           </p:cNvPr>
@@ -6296,10 +6596,10 @@
       </p:sp>
       <p:sp>
         <p:nvSpPr>
-          <p:cNvPr id="15" name="">
+          <p:cNvPr id="16" name="">
             <a:extLst xmlns:a="http://schemas.openxmlformats.org/drawingml/2006/main">
               <a:ext uri="{FF2B5EF4-FFF2-40B4-BE49-F238E27FC236}">
-                <a16:creationId xmlns:a16="http://schemas.microsoft.com/office/drawing/2014/main" id="{1E57E974-2BBA-4045-B971-7947B9002DD9}"/>
+                <a16:creationId xmlns:a16="http://schemas.microsoft.com/office/drawing/2014/main" id="{5A9E6D00-7CB2-4585-AEB3-76238A666773}"/>
               </a:ext>
             </a:extLst>
           </p:cNvPr>
@@ -6327,10 +6627,10 @@
       </p:sp>
       <p:sp>
         <p:nvSpPr>
-          <p:cNvPr id="16" name="flow-Volunteer collects">
+          <p:cNvPr id="17" name="flow-Volunteer collects">
             <a:extLst xmlns:a="http://schemas.openxmlformats.org/drawingml/2006/main">
               <a:ext uri="{FF2B5EF4-FFF2-40B4-BE49-F238E27FC236}">
-                <a16:creationId xmlns:a16="http://schemas.microsoft.com/office/drawing/2014/main" id="{A9F32C6D-4913-42C3-AB49-8A684276A5CD}"/>
+                <a16:creationId xmlns:a16="http://schemas.microsoft.com/office/drawing/2014/main" id="{68AB2616-32AB-4F17-8587-730275C8E18D}"/>
               </a:ext>
             </a:extLst>
           </p:cNvPr>
@@ -6362,10 +6662,10 @@
       </p:sp>
       <p:sp>
         <p:nvSpPr>
-          <p:cNvPr id="17" name="">
+          <p:cNvPr id="18" name="">
             <a:extLst xmlns:a="http://schemas.openxmlformats.org/drawingml/2006/main">
               <a:ext uri="{FF2B5EF4-FFF2-40B4-BE49-F238E27FC236}">
-                <a16:creationId xmlns:a16="http://schemas.microsoft.com/office/drawing/2014/main" id="{FBDA1317-37C0-44F8-BD5D-ABBE8F74EE4C}"/>
+                <a16:creationId xmlns:a16="http://schemas.microsoft.com/office/drawing/2014/main" id="{A49B4B5C-60E1-486D-9445-B279A7ACD7C5}"/>
               </a:ext>
             </a:extLst>
           </p:cNvPr>
@@ -6431,10 +6731,10 @@
       </p:sp>
       <p:sp>
         <p:nvSpPr>
-          <p:cNvPr id="18" name="">
+          <p:cNvPr id="19" name="">
             <a:extLst xmlns:a="http://schemas.openxmlformats.org/drawingml/2006/main">
               <a:ext uri="{FF2B5EF4-FFF2-40B4-BE49-F238E27FC236}">
-                <a16:creationId xmlns:a16="http://schemas.microsoft.com/office/drawing/2014/main" id="{5CF575F3-93B6-4F44-92FF-53C343B3DC48}"/>
+                <a16:creationId xmlns:a16="http://schemas.microsoft.com/office/drawing/2014/main" id="{008EA760-081A-4193-868C-F97B030E4BA2}"/>
               </a:ext>
             </a:extLst>
           </p:cNvPr>
@@ -6500,10 +6800,10 @@
       </p:sp>
       <p:sp>
         <p:nvSpPr>
-          <p:cNvPr id="19" name="">
+          <p:cNvPr id="20" name="">
             <a:extLst xmlns:a="http://schemas.openxmlformats.org/drawingml/2006/main">
               <a:ext uri="{FF2B5EF4-FFF2-40B4-BE49-F238E27FC236}">
-                <a16:creationId xmlns:a16="http://schemas.microsoft.com/office/drawing/2014/main" id="{F40E0E8F-6BB7-47AF-B022-CE771A258535}"/>
+                <a16:creationId xmlns:a16="http://schemas.microsoft.com/office/drawing/2014/main" id="{707B8AE9-CAAE-48CE-AED0-E6218783B678}"/>
               </a:ext>
             </a:extLst>
           </p:cNvPr>
@@ -6531,10 +6831,10 @@
       </p:sp>
       <p:sp>
         <p:nvSpPr>
-          <p:cNvPr id="20" name="flow-Delivered">
+          <p:cNvPr id="21" name="flow-Delivered">
             <a:extLst xmlns:a="http://schemas.openxmlformats.org/drawingml/2006/main">
               <a:ext uri="{FF2B5EF4-FFF2-40B4-BE49-F238E27FC236}">
-                <a16:creationId xmlns:a16="http://schemas.microsoft.com/office/drawing/2014/main" id="{899B436C-D69F-45B3-A3BD-98DEB15060E6}"/>
+                <a16:creationId xmlns:a16="http://schemas.microsoft.com/office/drawing/2014/main" id="{18818453-3312-4C33-9812-0727038EEAF0}"/>
               </a:ext>
             </a:extLst>
           </p:cNvPr>
@@ -6566,10 +6866,10 @@
       </p:sp>
       <p:sp>
         <p:nvSpPr>
-          <p:cNvPr id="21" name="">
+          <p:cNvPr id="22" name="">
             <a:extLst xmlns:a="http://schemas.openxmlformats.org/drawingml/2006/main">
               <a:ext uri="{FF2B5EF4-FFF2-40B4-BE49-F238E27FC236}">
-                <a16:creationId xmlns:a16="http://schemas.microsoft.com/office/drawing/2014/main" id="{651181B1-0B6B-4278-B686-9FCD0F0ED1A0}"/>
+                <a16:creationId xmlns:a16="http://schemas.microsoft.com/office/drawing/2014/main" id="{3A430D6B-CA58-4FBF-8201-8C564FCE548F}"/>
               </a:ext>
             </a:extLst>
           </p:cNvPr>
@@ -6635,10 +6935,10 @@
       </p:sp>
       <p:sp>
         <p:nvSpPr>
-          <p:cNvPr id="22" name="">
+          <p:cNvPr id="23" name="">
             <a:extLst xmlns:a="http://schemas.openxmlformats.org/drawingml/2006/main">
               <a:ext uri="{FF2B5EF4-FFF2-40B4-BE49-F238E27FC236}">
-                <a16:creationId xmlns:a16="http://schemas.microsoft.com/office/drawing/2014/main" id="{3C2EDB4F-E2DC-4B79-8695-E2A70B230352}"/>
+                <a16:creationId xmlns:a16="http://schemas.microsoft.com/office/drawing/2014/main" id="{54115679-2080-4CBE-8BDF-126ECCAFBAD5}"/>
               </a:ext>
             </a:extLst>
           </p:cNvPr>
@@ -6704,10 +7004,10 @@
       </p:sp>
       <p:sp>
         <p:nvSpPr>
-          <p:cNvPr id="23" name="">
+          <p:cNvPr id="24" name="">
             <a:extLst xmlns:a="http://schemas.openxmlformats.org/drawingml/2006/main">
               <a:ext uri="{FF2B5EF4-FFF2-40B4-BE49-F238E27FC236}">
-                <a16:creationId xmlns:a16="http://schemas.microsoft.com/office/drawing/2014/main" id="{EFAC09A6-D1CD-4C60-8B37-4CA3015E4487}"/>
+                <a16:creationId xmlns:a16="http://schemas.microsoft.com/office/drawing/2014/main" id="{23BCEA2D-E2FC-4597-9505-96554758D865}"/>
               </a:ext>
             </a:extLst>
           </p:cNvPr>
@@ -6735,10 +7035,10 @@
       </p:sp>
       <p:sp>
         <p:nvSpPr>
-          <p:cNvPr id="24" name="flow-Reports update">
+          <p:cNvPr id="25" name="flow-Reports update">
             <a:extLst xmlns:a="http://schemas.openxmlformats.org/drawingml/2006/main">
               <a:ext uri="{FF2B5EF4-FFF2-40B4-BE49-F238E27FC236}">
-                <a16:creationId xmlns:a16="http://schemas.microsoft.com/office/drawing/2014/main" id="{8B8DC02C-3EE8-4164-A851-8CBE271F5579}"/>
+                <a16:creationId xmlns:a16="http://schemas.microsoft.com/office/drawing/2014/main" id="{1E38C2D0-EA07-4CFE-83DD-C42CFEBE5C44}"/>
               </a:ext>
             </a:extLst>
           </p:cNvPr>
@@ -6770,10 +7070,10 @@
       </p:sp>
       <p:sp>
         <p:nvSpPr>
-          <p:cNvPr id="25" name="">
+          <p:cNvPr id="26" name="">
             <a:extLst xmlns:a="http://schemas.openxmlformats.org/drawingml/2006/main">
               <a:ext uri="{FF2B5EF4-FFF2-40B4-BE49-F238E27FC236}">
-                <a16:creationId xmlns:a16="http://schemas.microsoft.com/office/drawing/2014/main" id="{6E33F6C2-E545-43B5-8C4E-5AD08AD28F3B}"/>
+                <a16:creationId xmlns:a16="http://schemas.microsoft.com/office/drawing/2014/main" id="{8D44B3B8-5B79-4FA4-B5B0-3F0F3B1F2935}"/>
               </a:ext>
             </a:extLst>
           </p:cNvPr>
@@ -6839,10 +7139,10 @@
       </p:sp>
       <p:sp>
         <p:nvSpPr>
-          <p:cNvPr id="26" name="">
+          <p:cNvPr id="27" name="">
             <a:extLst xmlns:a="http://schemas.openxmlformats.org/drawingml/2006/main">
               <a:ext uri="{FF2B5EF4-FFF2-40B4-BE49-F238E27FC236}">
-                <a16:creationId xmlns:a16="http://schemas.microsoft.com/office/drawing/2014/main" id="{8F0E12FC-270B-4316-BB06-AED34602B9EC}"/>
+                <a16:creationId xmlns:a16="http://schemas.microsoft.com/office/drawing/2014/main" id="{B33D5A3F-E2AB-4A7D-B963-3B6114EB06CE}"/>
               </a:ext>
             </a:extLst>
           </p:cNvPr>
@@ -6908,10 +7208,10 @@
       </p:sp>
       <p:sp>
         <p:nvSpPr>
-          <p:cNvPr id="27" name="">
+          <p:cNvPr id="28" name="">
             <a:extLst xmlns:a="http://schemas.openxmlformats.org/drawingml/2006/main">
               <a:ext uri="{FF2B5EF4-FFF2-40B4-BE49-F238E27FC236}">
-                <a16:creationId xmlns:a16="http://schemas.microsoft.com/office/drawing/2014/main" id="{8EC91AD0-77A2-44DB-9343-26263CD35FA5}"/>
+                <a16:creationId xmlns:a16="http://schemas.microsoft.com/office/drawing/2014/main" id="{B65F9E5E-D721-4B19-BBA0-3ADA2178E585}"/>
               </a:ext>
             </a:extLst>
           </p:cNvPr>
@@ -7036,7 +7336,7 @@
     </p:spTree>
     <p:extLst>
       <p:ext uri="{BB962C8B-B14F-4D97-AF65-F5344CB8AC3E}">
-        <p14:creationId xmlns:p14="http://schemas.microsoft.com/office/powerpoint/2010/main" val="264892678"/>
+        <p14:creationId xmlns:p14="http://schemas.microsoft.com/office/powerpoint/2010/main" val="1174392729"/>
       </p:ext>
     </p:extLst>
   </p:cSld>
@@ -7064,10 +7364,79 @@
       </p:grpSpPr>
       <p:sp>
         <p:nvSpPr>
-          <p:cNvPr id="16" name="slide-title">
+          <p:cNvPr id="17" name="">
             <a:extLst xmlns:a="http://schemas.openxmlformats.org/drawingml/2006/main">
               <a:ext uri="{FF2B5EF4-FFF2-40B4-BE49-F238E27FC236}">
-                <a16:creationId xmlns:a16="http://schemas.microsoft.com/office/drawing/2014/main" id="{A8A69A7C-B46A-4F2F-B779-32F70E6896A4}"/>
+                <a16:creationId xmlns:a16="http://schemas.microsoft.com/office/drawing/2014/main" id="{05247537-0558-4EA0-96EE-5E091BC8D511}"/>
+              </a:ext>
+            </a:extLst>
+          </p:cNvPr>
+          <p:cNvSpPr>
+            <a:spLocks xmlns:a="http://schemas.openxmlformats.org/drawingml/2006/main" noGrp="1"/>
+          </p:cNvSpPr>
+          <p:nvPr/>
+        </p:nvSpPr>
+        <p:spPr>
+          <a:xfrm xmlns:a="http://schemas.openxmlformats.org/drawingml/2006/main">
+            <a:off x="9906000" y="552450"/>
+            <a:ext cx="1600200" cy="228600"/>
+          </a:xfrm>
+          <a:prstGeom xmlns:a="http://schemas.openxmlformats.org/drawingml/2006/main" prst="rect">
+            <a:avLst/>
+          </a:prstGeom>
+          <a:noFill xmlns:a="http://schemas.openxmlformats.org/drawingml/2006/main"/>
+          <a:ln xmlns:a="http://schemas.openxmlformats.org/drawingml/2006/main" w="0">
+            <a:noFill/>
+            <a:prstDash val="solid"/>
+          </a:ln>
+        </p:spPr>
+        <p:txBody>
+          <a:bodyPr xmlns:a="http://schemas.openxmlformats.org/drawingml/2006/main">
+            <a:noAutofit/>
+          </a:bodyPr>
+          <a:lstStyle xmlns:a="http://schemas.openxmlformats.org/drawingml/2006/main">
+            <a:defPPr>
+              <a:defRPr sz="975" b="0">
+                <a:solidFill>
+                  <a:srgbClr val="8A94A3"/>
+                </a:solidFill>
+                <a:latin typeface="Arial"/>
+                <a:ea typeface="Arial"/>
+                <a:cs typeface="Arial"/>
+              </a:defRPr>
+            </a:defPPr>
+          </a:lstStyle>
+          <a:p xmlns:a="http://schemas.openxmlformats.org/drawingml/2006/main">
+            <a:pPr>
+              <a:defRPr sz="975" b="0">
+                <a:solidFill>
+                  <a:srgbClr val="8A94A3"/>
+                </a:solidFill>
+                <a:latin typeface="Arial"/>
+                <a:ea typeface="Arial"/>
+                <a:cs typeface="Arial"/>
+              </a:defRPr>
+            </a:pPr>
+            <a:r>
+              <a:rPr sz="975" b="0">
+                <a:solidFill>
+                  <a:srgbClr val="8A94A3"/>
+                </a:solidFill>
+                <a:latin typeface="Arial"/>
+                <a:ea typeface="Arial"/>
+                <a:cs typeface="Arial"/>
+              </a:rPr>
+              <a:t>5 / 10</a:t>
+            </a:r>
+          </a:p>
+        </p:txBody>
+      </p:sp>
+      <p:sp>
+        <p:nvSpPr>
+          <p:cNvPr id="2" name="slide-title">
+            <a:extLst xmlns:a="http://schemas.openxmlformats.org/drawingml/2006/main">
+              <a:ext uri="{FF2B5EF4-FFF2-40B4-BE49-F238E27FC236}">
+                <a16:creationId xmlns:a16="http://schemas.microsoft.com/office/drawing/2014/main" id="{58A28E88-71E5-4B17-9994-2077F330245F}"/>
               </a:ext>
             </a:extLst>
           </p:cNvPr>
@@ -7133,10 +7502,10 @@
       </p:sp>
       <p:sp>
         <p:nvSpPr>
-          <p:cNvPr id="2" name="slide-lead">
+          <p:cNvPr id="3" name="slide-lead">
             <a:extLst xmlns:a="http://schemas.openxmlformats.org/drawingml/2006/main">
               <a:ext uri="{FF2B5EF4-FFF2-40B4-BE49-F238E27FC236}">
-                <a16:creationId xmlns:a16="http://schemas.microsoft.com/office/drawing/2014/main" id="{A65DD892-6CDE-4928-B7DB-D272274F3296}"/>
+                <a16:creationId xmlns:a16="http://schemas.microsoft.com/office/drawing/2014/main" id="{2EB507D3-9C05-4801-85FA-42331EC0342E}"/>
               </a:ext>
             </a:extLst>
           </p:cNvPr>
@@ -7202,10 +7571,10 @@
       </p:sp>
       <p:sp>
         <p:nvSpPr>
-          <p:cNvPr id="3" name="title-rule">
+          <p:cNvPr id="4" name="title-rule">
             <a:extLst xmlns:a="http://schemas.openxmlformats.org/drawingml/2006/main">
               <a:ext uri="{FF2B5EF4-FFF2-40B4-BE49-F238E27FC236}">
-                <a16:creationId xmlns:a16="http://schemas.microsoft.com/office/drawing/2014/main" id="{A5C068B8-56A2-403E-A8F5-5A363209112F}"/>
+                <a16:creationId xmlns:a16="http://schemas.microsoft.com/office/drawing/2014/main" id="{E4A558E2-DD14-4E33-9B61-A6B601AE800E}"/>
               </a:ext>
             </a:extLst>
           </p:cNvPr>
@@ -7233,10 +7602,10 @@
       </p:sp>
       <p:sp>
         <p:nvSpPr>
-          <p:cNvPr id="4" name="flow-Verified organization">
+          <p:cNvPr id="5" name="flow-Verified organization">
             <a:extLst xmlns:a="http://schemas.openxmlformats.org/drawingml/2006/main">
               <a:ext uri="{FF2B5EF4-FFF2-40B4-BE49-F238E27FC236}">
-                <a16:creationId xmlns:a16="http://schemas.microsoft.com/office/drawing/2014/main" id="{E6352121-D19B-4B0B-871D-AC73CF2BEFD1}"/>
+                <a16:creationId xmlns:a16="http://schemas.microsoft.com/office/drawing/2014/main" id="{6874194E-A8C2-4795-BB21-3A3535C0CC14}"/>
               </a:ext>
             </a:extLst>
           </p:cNvPr>
@@ -7268,10 +7637,10 @@
       </p:sp>
       <p:sp>
         <p:nvSpPr>
-          <p:cNvPr id="5" name="">
+          <p:cNvPr id="6" name="">
             <a:extLst xmlns:a="http://schemas.openxmlformats.org/drawingml/2006/main">
               <a:ext uri="{FF2B5EF4-FFF2-40B4-BE49-F238E27FC236}">
-                <a16:creationId xmlns:a16="http://schemas.microsoft.com/office/drawing/2014/main" id="{7086E342-7555-47B0-93F4-99BF838162CD}"/>
+                <a16:creationId xmlns:a16="http://schemas.microsoft.com/office/drawing/2014/main" id="{6F14FDAE-A329-4D87-90B4-4C3504C8D5E6}"/>
               </a:ext>
             </a:extLst>
           </p:cNvPr>
@@ -7337,10 +7706,10 @@
       </p:sp>
       <p:sp>
         <p:nvSpPr>
-          <p:cNvPr id="6" name="">
+          <p:cNvPr id="7" name="">
             <a:extLst xmlns:a="http://schemas.openxmlformats.org/drawingml/2006/main">
               <a:ext uri="{FF2B5EF4-FFF2-40B4-BE49-F238E27FC236}">
-                <a16:creationId xmlns:a16="http://schemas.microsoft.com/office/drawing/2014/main" id="{0A6E79C8-8039-4B03-A756-9486937BDDE4}"/>
+                <a16:creationId xmlns:a16="http://schemas.microsoft.com/office/drawing/2014/main" id="{659DE63A-E602-4407-ACE9-8AEE7F0CB301}"/>
               </a:ext>
             </a:extLst>
           </p:cNvPr>
@@ -7368,10 +7737,10 @@
       </p:sp>
       <p:sp>
         <p:nvSpPr>
-          <p:cNvPr id="7" name="flow-Sufficient free storage">
+          <p:cNvPr id="8" name="flow-Sufficient free storage">
             <a:extLst xmlns:a="http://schemas.openxmlformats.org/drawingml/2006/main">
               <a:ext uri="{FF2B5EF4-FFF2-40B4-BE49-F238E27FC236}">
-                <a16:creationId xmlns:a16="http://schemas.microsoft.com/office/drawing/2014/main" id="{B818FF2D-73F0-4DAF-A5C0-9B84F3B1D8B0}"/>
+                <a16:creationId xmlns:a16="http://schemas.microsoft.com/office/drawing/2014/main" id="{B57661CE-44E3-471D-87E7-EF4D5360E99F}"/>
               </a:ext>
             </a:extLst>
           </p:cNvPr>
@@ -7403,10 +7772,10 @@
       </p:sp>
       <p:sp>
         <p:nvSpPr>
-          <p:cNvPr id="8" name="">
+          <p:cNvPr id="9" name="">
             <a:extLst xmlns:a="http://schemas.openxmlformats.org/drawingml/2006/main">
               <a:ext uri="{FF2B5EF4-FFF2-40B4-BE49-F238E27FC236}">
-                <a16:creationId xmlns:a16="http://schemas.microsoft.com/office/drawing/2014/main" id="{93AA7D86-9812-4294-AE79-6E4C8CD6BA9F}"/>
+                <a16:creationId xmlns:a16="http://schemas.microsoft.com/office/drawing/2014/main" id="{444F9BA8-38DD-4CE0-A5B9-E8BC0E4E4297}"/>
               </a:ext>
             </a:extLst>
           </p:cNvPr>
@@ -7472,10 +7841,10 @@
       </p:sp>
       <p:sp>
         <p:nvSpPr>
-          <p:cNvPr id="9" name="">
+          <p:cNvPr id="10" name="">
             <a:extLst xmlns:a="http://schemas.openxmlformats.org/drawingml/2006/main">
               <a:ext uri="{FF2B5EF4-FFF2-40B4-BE49-F238E27FC236}">
-                <a16:creationId xmlns:a16="http://schemas.microsoft.com/office/drawing/2014/main" id="{D8F5DAD6-C105-41FD-A72B-0ECBDE87F0B4}"/>
+                <a16:creationId xmlns:a16="http://schemas.microsoft.com/office/drawing/2014/main" id="{77FA1D2B-9251-454E-BD8F-6BC2D81FC086}"/>
               </a:ext>
             </a:extLst>
           </p:cNvPr>
@@ -7503,10 +7872,10 @@
       </p:sp>
       <p:sp>
         <p:nvSpPr>
-          <p:cNvPr id="10" name="flow-Category accepted">
+          <p:cNvPr id="11" name="flow-Category accepted">
             <a:extLst xmlns:a="http://schemas.openxmlformats.org/drawingml/2006/main">
               <a:ext uri="{FF2B5EF4-FFF2-40B4-BE49-F238E27FC236}">
-                <a16:creationId xmlns:a16="http://schemas.microsoft.com/office/drawing/2014/main" id="{DE6D3ABA-822D-4D71-A806-F4DA985EE604}"/>
+                <a16:creationId xmlns:a16="http://schemas.microsoft.com/office/drawing/2014/main" id="{B1BC4466-DAB2-47DB-BFB2-96D0C0BF1DD5}"/>
               </a:ext>
             </a:extLst>
           </p:cNvPr>
@@ -7538,10 +7907,10 @@
       </p:sp>
       <p:sp>
         <p:nvSpPr>
-          <p:cNvPr id="11" name="">
+          <p:cNvPr id="12" name="">
             <a:extLst xmlns:a="http://schemas.openxmlformats.org/drawingml/2006/main">
               <a:ext uri="{FF2B5EF4-FFF2-40B4-BE49-F238E27FC236}">
-                <a16:creationId xmlns:a16="http://schemas.microsoft.com/office/drawing/2014/main" id="{A38390E9-0EA1-43B2-A34C-6588A7E0CED6}"/>
+                <a16:creationId xmlns:a16="http://schemas.microsoft.com/office/drawing/2014/main" id="{EC5A170E-90B2-4312-B202-3A7AED4C2B1D}"/>
               </a:ext>
             </a:extLst>
           </p:cNvPr>
@@ -7607,10 +7976,10 @@
       </p:sp>
       <p:sp>
         <p:nvSpPr>
-          <p:cNvPr id="12" name="">
+          <p:cNvPr id="13" name="">
             <a:extLst xmlns:a="http://schemas.openxmlformats.org/drawingml/2006/main">
               <a:ext uri="{FF2B5EF4-FFF2-40B4-BE49-F238E27FC236}">
-                <a16:creationId xmlns:a16="http://schemas.microsoft.com/office/drawing/2014/main" id="{D625176A-17C7-45A9-859B-0A7C0D270D8F}"/>
+                <a16:creationId xmlns:a16="http://schemas.microsoft.com/office/drawing/2014/main" id="{F1FA620A-4C6B-43EA-AD96-6A94EC0A7406}"/>
               </a:ext>
             </a:extLst>
           </p:cNvPr>
@@ -7638,10 +8007,10 @@
       </p:sp>
       <p:sp>
         <p:nvSpPr>
-          <p:cNvPr id="13" name="flow-Safe arrival feasible">
+          <p:cNvPr id="14" name="flow-Safe arrival feasible">
             <a:extLst xmlns:a="http://schemas.openxmlformats.org/drawingml/2006/main">
               <a:ext uri="{FF2B5EF4-FFF2-40B4-BE49-F238E27FC236}">
-                <a16:creationId xmlns:a16="http://schemas.microsoft.com/office/drawing/2014/main" id="{4A3FBFAB-6BA7-42EE-AD21-1932E431B22B}"/>
+                <a16:creationId xmlns:a16="http://schemas.microsoft.com/office/drawing/2014/main" id="{94FB40AD-59B3-4F7A-91AE-3E99B4A63D56}"/>
               </a:ext>
             </a:extLst>
           </p:cNvPr>
@@ -7673,10 +8042,10 @@
       </p:sp>
       <p:sp>
         <p:nvSpPr>
-          <p:cNvPr id="14" name="">
+          <p:cNvPr id="15" name="">
             <a:extLst xmlns:a="http://schemas.openxmlformats.org/drawingml/2006/main">
               <a:ext uri="{FF2B5EF4-FFF2-40B4-BE49-F238E27FC236}">
-                <a16:creationId xmlns:a16="http://schemas.microsoft.com/office/drawing/2014/main" id="{F602F6E3-4427-48DB-8EE0-E8AC67ADDFBE}"/>
+                <a16:creationId xmlns:a16="http://schemas.microsoft.com/office/drawing/2014/main" id="{23AB785E-DDFF-420A-8331-A4B63884E2D6}"/>
               </a:ext>
             </a:extLst>
           </p:cNvPr>
@@ -7742,10 +8111,10 @@
       </p:sp>
       <p:graphicFrame>
         <p:nvGraphicFramePr>
-          <p:cNvPr id="15" name="">
+          <p:cNvPr id="16" name="">
             <a:extLst xmlns:a="http://schemas.openxmlformats.org/drawingml/2006/main">
               <a:ext uri="{FF2B5EF4-FFF2-40B4-BE49-F238E27FC236}">
-                <a16:creationId xmlns:a16="http://schemas.microsoft.com/office/drawing/2014/main" id="{6D4F1703-5253-4250-B084-8F3EC5CB49F2}"/>
+                <a16:creationId xmlns:a16="http://schemas.microsoft.com/office/drawing/2014/main" id="{EB8CCEF4-7E82-4EB3-9DD2-8C9CA3B6B93D}"/>
               </a:ext>
             </a:extLst>
           </p:cNvPr>
@@ -8260,7 +8629,7 @@
     </p:spTree>
     <p:extLst>
       <p:ext uri="{BB962C8B-B14F-4D97-AF65-F5344CB8AC3E}">
-        <p14:creationId xmlns:p14="http://schemas.microsoft.com/office/powerpoint/2010/main" val="38310853"/>
+        <p14:creationId xmlns:p14="http://schemas.microsoft.com/office/powerpoint/2010/main" val="143537874"/>
       </p:ext>
     </p:extLst>
   </p:cSld>
@@ -8288,10 +8657,79 @@
       </p:grpSpPr>
       <p:sp>
         <p:nvSpPr>
-          <p:cNvPr id="8" name="slide-title">
+          <p:cNvPr id="9" name="">
             <a:extLst xmlns:a="http://schemas.openxmlformats.org/drawingml/2006/main">
               <a:ext uri="{FF2B5EF4-FFF2-40B4-BE49-F238E27FC236}">
-                <a16:creationId xmlns:a16="http://schemas.microsoft.com/office/drawing/2014/main" id="{7C1DC4F3-E779-4675-B876-608F12F77AC8}"/>
+                <a16:creationId xmlns:a16="http://schemas.microsoft.com/office/drawing/2014/main" id="{48723FFB-F9D0-4565-BC32-E1A27C676F07}"/>
+              </a:ext>
+            </a:extLst>
+          </p:cNvPr>
+          <p:cNvSpPr>
+            <a:spLocks xmlns:a="http://schemas.openxmlformats.org/drawingml/2006/main" noGrp="1"/>
+          </p:cNvSpPr>
+          <p:nvPr/>
+        </p:nvSpPr>
+        <p:spPr>
+          <a:xfrm xmlns:a="http://schemas.openxmlformats.org/drawingml/2006/main">
+            <a:off x="9906000" y="552450"/>
+            <a:ext cx="1600200" cy="228600"/>
+          </a:xfrm>
+          <a:prstGeom xmlns:a="http://schemas.openxmlformats.org/drawingml/2006/main" prst="rect">
+            <a:avLst/>
+          </a:prstGeom>
+          <a:noFill xmlns:a="http://schemas.openxmlformats.org/drawingml/2006/main"/>
+          <a:ln xmlns:a="http://schemas.openxmlformats.org/drawingml/2006/main" w="0">
+            <a:noFill/>
+            <a:prstDash val="solid"/>
+          </a:ln>
+        </p:spPr>
+        <p:txBody>
+          <a:bodyPr xmlns:a="http://schemas.openxmlformats.org/drawingml/2006/main">
+            <a:noAutofit/>
+          </a:bodyPr>
+          <a:lstStyle xmlns:a="http://schemas.openxmlformats.org/drawingml/2006/main">
+            <a:defPPr>
+              <a:defRPr sz="975" b="0">
+                <a:solidFill>
+                  <a:srgbClr val="8A94A3"/>
+                </a:solidFill>
+                <a:latin typeface="Arial"/>
+                <a:ea typeface="Arial"/>
+                <a:cs typeface="Arial"/>
+              </a:defRPr>
+            </a:defPPr>
+          </a:lstStyle>
+          <a:p xmlns:a="http://schemas.openxmlformats.org/drawingml/2006/main">
+            <a:pPr>
+              <a:defRPr sz="975" b="0">
+                <a:solidFill>
+                  <a:srgbClr val="8A94A3"/>
+                </a:solidFill>
+                <a:latin typeface="Arial"/>
+                <a:ea typeface="Arial"/>
+                <a:cs typeface="Arial"/>
+              </a:defRPr>
+            </a:pPr>
+            <a:r>
+              <a:rPr sz="975" b="0">
+                <a:solidFill>
+                  <a:srgbClr val="8A94A3"/>
+                </a:solidFill>
+                <a:latin typeface="Arial"/>
+                <a:ea typeface="Arial"/>
+                <a:cs typeface="Arial"/>
+              </a:rPr>
+              <a:t>6 / 10</a:t>
+            </a:r>
+          </a:p>
+        </p:txBody>
+      </p:sp>
+      <p:sp>
+        <p:nvSpPr>
+          <p:cNvPr id="2" name="slide-title">
+            <a:extLst xmlns:a="http://schemas.openxmlformats.org/drawingml/2006/main">
+              <a:ext uri="{FF2B5EF4-FFF2-40B4-BE49-F238E27FC236}">
+                <a16:creationId xmlns:a16="http://schemas.microsoft.com/office/drawing/2014/main" id="{AB3B984B-06C6-4B91-83A7-B9F8CA7ECC55}"/>
               </a:ext>
             </a:extLst>
           </p:cNvPr>
@@ -8357,10 +8795,10 @@
       </p:sp>
       <p:sp>
         <p:nvSpPr>
-          <p:cNvPr id="2" name="slide-lead">
+          <p:cNvPr id="3" name="slide-lead">
             <a:extLst xmlns:a="http://schemas.openxmlformats.org/drawingml/2006/main">
               <a:ext uri="{FF2B5EF4-FFF2-40B4-BE49-F238E27FC236}">
-                <a16:creationId xmlns:a16="http://schemas.microsoft.com/office/drawing/2014/main" id="{39E99AF6-0746-4CDD-BE8A-9A5DE7400C9A}"/>
+                <a16:creationId xmlns:a16="http://schemas.microsoft.com/office/drawing/2014/main" id="{65DCB607-DDF4-4503-9593-0635391F0081}"/>
               </a:ext>
             </a:extLst>
           </p:cNvPr>
@@ -8426,10 +8864,10 @@
       </p:sp>
       <p:sp>
         <p:nvSpPr>
-          <p:cNvPr id="3" name="title-rule">
+          <p:cNvPr id="4" name="title-rule">
             <a:extLst xmlns:a="http://schemas.openxmlformats.org/drawingml/2006/main">
               <a:ext uri="{FF2B5EF4-FFF2-40B4-BE49-F238E27FC236}">
-                <a16:creationId xmlns:a16="http://schemas.microsoft.com/office/drawing/2014/main" id="{F7CA7AE4-75A3-44C6-9245-081544D4F427}"/>
+                <a16:creationId xmlns:a16="http://schemas.microsoft.com/office/drawing/2014/main" id="{4DAFFD3B-08C5-489D-952E-A77DEDF3FE3D}"/>
               </a:ext>
             </a:extLst>
           </p:cNvPr>
@@ -8457,10 +8895,10 @@
       </p:sp>
       <p:sp>
         <p:nvSpPr>
-          <p:cNvPr id="4" name="">
+          <p:cNvPr id="5" name="">
             <a:extLst xmlns:a="http://schemas.openxmlformats.org/drawingml/2006/main">
               <a:ext uri="{FF2B5EF4-FFF2-40B4-BE49-F238E27FC236}">
-                <a16:creationId xmlns:a16="http://schemas.microsoft.com/office/drawing/2014/main" id="{B66856B0-5F4A-4C91-A9D4-B7C2BC7FAC01}"/>
+                <a16:creationId xmlns:a16="http://schemas.microsoft.com/office/drawing/2014/main" id="{A0FFB62A-FF47-4C13-AE14-A07C6C030DB6}"/>
               </a:ext>
             </a:extLst>
           </p:cNvPr>
@@ -8611,10 +9049,10 @@
       </p:sp>
       <p:graphicFrame>
         <p:nvGraphicFramePr>
-          <p:cNvPr id="5" name="">
+          <p:cNvPr id="6" name="">
             <a:extLst xmlns:a="http://schemas.openxmlformats.org/drawingml/2006/main">
               <a:ext uri="{FF2B5EF4-FFF2-40B4-BE49-F238E27FC236}">
-                <a16:creationId xmlns:a16="http://schemas.microsoft.com/office/drawing/2014/main" id="{155723FF-EA16-4E62-91B2-F82BC95F2DDC}"/>
+                <a16:creationId xmlns:a16="http://schemas.microsoft.com/office/drawing/2014/main" id="{5573B96E-6255-43A9-9672-3E27054EEA58}"/>
               </a:ext>
             </a:extLst>
           </p:cNvPr>
@@ -8924,10 +9362,10 @@
       </p:graphicFrame>
       <p:sp>
         <p:nvSpPr>
-          <p:cNvPr id="6" name="">
+          <p:cNvPr id="7" name="">
             <a:extLst xmlns:a="http://schemas.openxmlformats.org/drawingml/2006/main">
               <a:ext uri="{FF2B5EF4-FFF2-40B4-BE49-F238E27FC236}">
-                <a16:creationId xmlns:a16="http://schemas.microsoft.com/office/drawing/2014/main" id="{602FF57D-AD8D-4285-8590-DA97B8F30BAE}"/>
+                <a16:creationId xmlns:a16="http://schemas.microsoft.com/office/drawing/2014/main" id="{F15B3B74-62EB-4E24-B85D-8BB2BCF9CCC3}"/>
               </a:ext>
             </a:extLst>
           </p:cNvPr>
@@ -8993,10 +9431,10 @@
       </p:sp>
       <p:sp>
         <p:nvSpPr>
-          <p:cNvPr id="7" name="">
+          <p:cNvPr id="8" name="">
             <a:extLst xmlns:a="http://schemas.openxmlformats.org/drawingml/2006/main">
               <a:ext uri="{FF2B5EF4-FFF2-40B4-BE49-F238E27FC236}">
-                <a16:creationId xmlns:a16="http://schemas.microsoft.com/office/drawing/2014/main" id="{2A4D6A2D-6C93-4F20-804B-05BC405CB424}"/>
+                <a16:creationId xmlns:a16="http://schemas.microsoft.com/office/drawing/2014/main" id="{B6FCA08B-74DC-4C4A-80A9-E941E9BABDCD}"/>
               </a:ext>
             </a:extLst>
           </p:cNvPr>
@@ -9063,7 +9501,7 @@
     </p:spTree>
     <p:extLst>
       <p:ext uri="{BB962C8B-B14F-4D97-AF65-F5344CB8AC3E}">
-        <p14:creationId xmlns:p14="http://schemas.microsoft.com/office/powerpoint/2010/main" val="1948774898"/>
+        <p14:creationId xmlns:p14="http://schemas.microsoft.com/office/powerpoint/2010/main" val="1569713441"/>
       </p:ext>
     </p:extLst>
   </p:cSld>
@@ -9091,10 +9529,79 @@
       </p:grpSpPr>
       <p:sp>
         <p:nvSpPr>
-          <p:cNvPr id="7" name="slide-title">
+          <p:cNvPr id="8" name="">
             <a:extLst xmlns:a="http://schemas.openxmlformats.org/drawingml/2006/main">
               <a:ext uri="{FF2B5EF4-FFF2-40B4-BE49-F238E27FC236}">
-                <a16:creationId xmlns:a16="http://schemas.microsoft.com/office/drawing/2014/main" id="{453F484C-D1CE-4E12-B6CA-512B5649BD7D}"/>
+                <a16:creationId xmlns:a16="http://schemas.microsoft.com/office/drawing/2014/main" id="{DCFAB488-3943-43A4-8E9A-253391755B8A}"/>
+              </a:ext>
+            </a:extLst>
+          </p:cNvPr>
+          <p:cNvSpPr>
+            <a:spLocks xmlns:a="http://schemas.openxmlformats.org/drawingml/2006/main" noGrp="1"/>
+          </p:cNvSpPr>
+          <p:nvPr/>
+        </p:nvSpPr>
+        <p:spPr>
+          <a:xfrm xmlns:a="http://schemas.openxmlformats.org/drawingml/2006/main">
+            <a:off x="9906000" y="552450"/>
+            <a:ext cx="1600200" cy="228600"/>
+          </a:xfrm>
+          <a:prstGeom xmlns:a="http://schemas.openxmlformats.org/drawingml/2006/main" prst="rect">
+            <a:avLst/>
+          </a:prstGeom>
+          <a:noFill xmlns:a="http://schemas.openxmlformats.org/drawingml/2006/main"/>
+          <a:ln xmlns:a="http://schemas.openxmlformats.org/drawingml/2006/main" w="0">
+            <a:noFill/>
+            <a:prstDash val="solid"/>
+          </a:ln>
+        </p:spPr>
+        <p:txBody>
+          <a:bodyPr xmlns:a="http://schemas.openxmlformats.org/drawingml/2006/main">
+            <a:noAutofit/>
+          </a:bodyPr>
+          <a:lstStyle xmlns:a="http://schemas.openxmlformats.org/drawingml/2006/main">
+            <a:defPPr>
+              <a:defRPr sz="975" b="0">
+                <a:solidFill>
+                  <a:srgbClr val="8A94A3"/>
+                </a:solidFill>
+                <a:latin typeface="Arial"/>
+                <a:ea typeface="Arial"/>
+                <a:cs typeface="Arial"/>
+              </a:defRPr>
+            </a:defPPr>
+          </a:lstStyle>
+          <a:p xmlns:a="http://schemas.openxmlformats.org/drawingml/2006/main">
+            <a:pPr>
+              <a:defRPr sz="975" b="0">
+                <a:solidFill>
+                  <a:srgbClr val="8A94A3"/>
+                </a:solidFill>
+                <a:latin typeface="Arial"/>
+                <a:ea typeface="Arial"/>
+                <a:cs typeface="Arial"/>
+              </a:defRPr>
+            </a:pPr>
+            <a:r>
+              <a:rPr sz="975" b="0">
+                <a:solidFill>
+                  <a:srgbClr val="8A94A3"/>
+                </a:solidFill>
+                <a:latin typeface="Arial"/>
+                <a:ea typeface="Arial"/>
+                <a:cs typeface="Arial"/>
+              </a:rPr>
+              <a:t>7 / 10</a:t>
+            </a:r>
+          </a:p>
+        </p:txBody>
+      </p:sp>
+      <p:sp>
+        <p:nvSpPr>
+          <p:cNvPr id="2" name="slide-title">
+            <a:extLst xmlns:a="http://schemas.openxmlformats.org/drawingml/2006/main">
+              <a:ext uri="{FF2B5EF4-FFF2-40B4-BE49-F238E27FC236}">
+                <a16:creationId xmlns:a16="http://schemas.microsoft.com/office/drawing/2014/main" id="{4284586E-F07E-4874-AC9F-76F19CA89DFC}"/>
               </a:ext>
             </a:extLst>
           </p:cNvPr>
@@ -9160,10 +9667,10 @@
       </p:sp>
       <p:sp>
         <p:nvSpPr>
-          <p:cNvPr id="2" name="slide-lead">
+          <p:cNvPr id="3" name="slide-lead">
             <a:extLst xmlns:a="http://schemas.openxmlformats.org/drawingml/2006/main">
               <a:ext uri="{FF2B5EF4-FFF2-40B4-BE49-F238E27FC236}">
-                <a16:creationId xmlns:a16="http://schemas.microsoft.com/office/drawing/2014/main" id="{5F9083AE-FDC8-49E1-BF02-C428374B0FC0}"/>
+                <a16:creationId xmlns:a16="http://schemas.microsoft.com/office/drawing/2014/main" id="{2D2FCC4E-22F0-4D55-81E8-D601F25F9544}"/>
               </a:ext>
             </a:extLst>
           </p:cNvPr>
@@ -9229,10 +9736,10 @@
       </p:sp>
       <p:sp>
         <p:nvSpPr>
-          <p:cNvPr id="3" name="title-rule">
+          <p:cNvPr id="4" name="title-rule">
             <a:extLst xmlns:a="http://schemas.openxmlformats.org/drawingml/2006/main">
               <a:ext uri="{FF2B5EF4-FFF2-40B4-BE49-F238E27FC236}">
-                <a16:creationId xmlns:a16="http://schemas.microsoft.com/office/drawing/2014/main" id="{2807768E-5B6F-4095-B75C-58D0D8C335F4}"/>
+                <a16:creationId xmlns:a16="http://schemas.microsoft.com/office/drawing/2014/main" id="{5DFA8683-6964-45C5-8449-0402F9CF1A9B}"/>
               </a:ext>
             </a:extLst>
           </p:cNvPr>
@@ -9260,10 +9767,10 @@
       </p:sp>
       <p:sp>
         <p:nvSpPr>
-          <p:cNvPr id="4" name="">
+          <p:cNvPr id="5" name="">
             <a:extLst xmlns:a="http://schemas.openxmlformats.org/drawingml/2006/main">
               <a:ext uri="{FF2B5EF4-FFF2-40B4-BE49-F238E27FC236}">
-                <a16:creationId xmlns:a16="http://schemas.microsoft.com/office/drawing/2014/main" id="{9C56AC5A-1513-4857-8553-34087F0D3F2C}"/>
+                <a16:creationId xmlns:a16="http://schemas.microsoft.com/office/drawing/2014/main" id="{AED90E97-470F-4642-A056-B90CA900E9DA}"/>
               </a:ext>
             </a:extLst>
           </p:cNvPr>
@@ -9387,10 +9894,10 @@
       </p:sp>
       <p:pic>
         <p:nvPicPr>
-          <p:cNvPr id="5" name="">
+          <p:cNvPr id="6" name="">
             <a:extLst xmlns:a="http://schemas.openxmlformats.org/drawingml/2006/main">
               <a:ext uri="{FF2B5EF4-FFF2-40B4-BE49-F238E27FC236}">
-                <a16:creationId xmlns:a16="http://schemas.microsoft.com/office/drawing/2014/main" id="{E2AFA96B-FEFB-4B58-91E0-FA0317695B24}"/>
+                <a16:creationId xmlns:a16="http://schemas.microsoft.com/office/drawing/2014/main" id="{6E30508E-550C-486D-877F-255CF8547F30}"/>
               </a:ext>
             </a:extLst>
           </p:cNvPr>
@@ -9400,7 +9907,7 @@
           <p:nvPr/>
         </p:nvPicPr>
         <p:blipFill>
-          <a:blip xmlns:r="http://schemas.openxmlformats.org/officeDocument/2006/relationships" xmlns:a="http://schemas.openxmlformats.org/drawingml/2006/main" r:embed="Re3a710d1becf43fb"/>
+          <a:blip xmlns:r="http://schemas.openxmlformats.org/officeDocument/2006/relationships" xmlns:a="http://schemas.openxmlformats.org/drawingml/2006/main" r:embed="R18dc9e5d9e7f4bd7"/>
           <a:stretch xmlns:a="http://schemas.openxmlformats.org/drawingml/2006/main"/>
         </p:blipFill>
         <p:spPr>
@@ -9415,10 +9922,10 @@
       </p:pic>
       <p:sp>
         <p:nvSpPr>
-          <p:cNvPr id="6" name="">
+          <p:cNvPr id="7" name="">
             <a:extLst xmlns:a="http://schemas.openxmlformats.org/drawingml/2006/main">
               <a:ext uri="{FF2B5EF4-FFF2-40B4-BE49-F238E27FC236}">
-                <a16:creationId xmlns:a16="http://schemas.microsoft.com/office/drawing/2014/main" id="{0C7DC1D8-2B5C-46C9-A36F-02B36E36FA6F}"/>
+                <a16:creationId xmlns:a16="http://schemas.microsoft.com/office/drawing/2014/main" id="{29BA8E67-73DC-4D42-B0C9-49D2E3AAE785}"/>
               </a:ext>
             </a:extLst>
           </p:cNvPr>
@@ -9485,7 +9992,7 @@
     </p:spTree>
     <p:extLst>
       <p:ext uri="{BB962C8B-B14F-4D97-AF65-F5344CB8AC3E}">
-        <p14:creationId xmlns:p14="http://schemas.microsoft.com/office/powerpoint/2010/main" val="1835746613"/>
+        <p14:creationId xmlns:p14="http://schemas.microsoft.com/office/powerpoint/2010/main" val="1569514512"/>
       </p:ext>
     </p:extLst>
   </p:cSld>
@@ -9513,10 +10020,79 @@
       </p:grpSpPr>
       <p:sp>
         <p:nvSpPr>
-          <p:cNvPr id="7" name="slide-title">
+          <p:cNvPr id="8" name="">
             <a:extLst xmlns:a="http://schemas.openxmlformats.org/drawingml/2006/main">
               <a:ext uri="{FF2B5EF4-FFF2-40B4-BE49-F238E27FC236}">
-                <a16:creationId xmlns:a16="http://schemas.microsoft.com/office/drawing/2014/main" id="{0192D80C-0EAB-4F1B-BEDA-07B723444A47}"/>
+                <a16:creationId xmlns:a16="http://schemas.microsoft.com/office/drawing/2014/main" id="{FDFDAFC2-D577-4B95-AE77-DE6C73AAC29B}"/>
+              </a:ext>
+            </a:extLst>
+          </p:cNvPr>
+          <p:cNvSpPr>
+            <a:spLocks xmlns:a="http://schemas.openxmlformats.org/drawingml/2006/main" noGrp="1"/>
+          </p:cNvSpPr>
+          <p:nvPr/>
+        </p:nvSpPr>
+        <p:spPr>
+          <a:xfrm xmlns:a="http://schemas.openxmlformats.org/drawingml/2006/main">
+            <a:off x="9906000" y="552450"/>
+            <a:ext cx="1600200" cy="228600"/>
+          </a:xfrm>
+          <a:prstGeom xmlns:a="http://schemas.openxmlformats.org/drawingml/2006/main" prst="rect">
+            <a:avLst/>
+          </a:prstGeom>
+          <a:noFill xmlns:a="http://schemas.openxmlformats.org/drawingml/2006/main"/>
+          <a:ln xmlns:a="http://schemas.openxmlformats.org/drawingml/2006/main" w="0">
+            <a:noFill/>
+            <a:prstDash val="solid"/>
+          </a:ln>
+        </p:spPr>
+        <p:txBody>
+          <a:bodyPr xmlns:a="http://schemas.openxmlformats.org/drawingml/2006/main">
+            <a:noAutofit/>
+          </a:bodyPr>
+          <a:lstStyle xmlns:a="http://schemas.openxmlformats.org/drawingml/2006/main">
+            <a:defPPr>
+              <a:defRPr sz="975" b="0">
+                <a:solidFill>
+                  <a:srgbClr val="8A94A3"/>
+                </a:solidFill>
+                <a:latin typeface="Arial"/>
+                <a:ea typeface="Arial"/>
+                <a:cs typeface="Arial"/>
+              </a:defRPr>
+            </a:defPPr>
+          </a:lstStyle>
+          <a:p xmlns:a="http://schemas.openxmlformats.org/drawingml/2006/main">
+            <a:pPr>
+              <a:defRPr sz="975" b="0">
+                <a:solidFill>
+                  <a:srgbClr val="8A94A3"/>
+                </a:solidFill>
+                <a:latin typeface="Arial"/>
+                <a:ea typeface="Arial"/>
+                <a:cs typeface="Arial"/>
+              </a:defRPr>
+            </a:pPr>
+            <a:r>
+              <a:rPr sz="975" b="0">
+                <a:solidFill>
+                  <a:srgbClr val="8A94A3"/>
+                </a:solidFill>
+                <a:latin typeface="Arial"/>
+                <a:ea typeface="Arial"/>
+                <a:cs typeface="Arial"/>
+              </a:rPr>
+              <a:t>8 / 10</a:t>
+            </a:r>
+          </a:p>
+        </p:txBody>
+      </p:sp>
+      <p:sp>
+        <p:nvSpPr>
+          <p:cNvPr id="2" name="slide-title">
+            <a:extLst xmlns:a="http://schemas.openxmlformats.org/drawingml/2006/main">
+              <a:ext uri="{FF2B5EF4-FFF2-40B4-BE49-F238E27FC236}">
+                <a16:creationId xmlns:a16="http://schemas.microsoft.com/office/drawing/2014/main" id="{F11C8DD1-09F2-440C-92FF-1BE968448174}"/>
               </a:ext>
             </a:extLst>
           </p:cNvPr>
@@ -9582,10 +10158,10 @@
       </p:sp>
       <p:sp>
         <p:nvSpPr>
-          <p:cNvPr id="2" name="slide-lead">
+          <p:cNvPr id="3" name="slide-lead">
             <a:extLst xmlns:a="http://schemas.openxmlformats.org/drawingml/2006/main">
               <a:ext uri="{FF2B5EF4-FFF2-40B4-BE49-F238E27FC236}">
-                <a16:creationId xmlns:a16="http://schemas.microsoft.com/office/drawing/2014/main" id="{686099FB-BF65-4A0F-BD3F-7C7758BFE1B7}"/>
+                <a16:creationId xmlns:a16="http://schemas.microsoft.com/office/drawing/2014/main" id="{6D50D0B7-9BB1-4C3B-AC4A-490CCBA0CFCD}"/>
               </a:ext>
             </a:extLst>
           </p:cNvPr>
@@ -9651,10 +10227,10 @@
       </p:sp>
       <p:sp>
         <p:nvSpPr>
-          <p:cNvPr id="3" name="title-rule">
+          <p:cNvPr id="4" name="title-rule">
             <a:extLst xmlns:a="http://schemas.openxmlformats.org/drawingml/2006/main">
               <a:ext uri="{FF2B5EF4-FFF2-40B4-BE49-F238E27FC236}">
-                <a16:creationId xmlns:a16="http://schemas.microsoft.com/office/drawing/2014/main" id="{DB6D6407-329D-4518-A156-A37DF0139807}"/>
+                <a16:creationId xmlns:a16="http://schemas.microsoft.com/office/drawing/2014/main" id="{A642BAF4-BF6C-4E71-8E46-0304B18DF1C7}"/>
               </a:ext>
             </a:extLst>
           </p:cNvPr>
@@ -9682,10 +10258,10 @@
       </p:sp>
       <p:sp>
         <p:nvSpPr>
-          <p:cNvPr id="4" name="">
+          <p:cNvPr id="5" name="">
             <a:extLst xmlns:a="http://schemas.openxmlformats.org/drawingml/2006/main">
               <a:ext uri="{FF2B5EF4-FFF2-40B4-BE49-F238E27FC236}">
-                <a16:creationId xmlns:a16="http://schemas.microsoft.com/office/drawing/2014/main" id="{9B194D4E-B08B-4564-81CF-08A147C8B756}"/>
+                <a16:creationId xmlns:a16="http://schemas.microsoft.com/office/drawing/2014/main" id="{73975328-5D85-432E-8EA0-EFA6A81C491B}"/>
               </a:ext>
             </a:extLst>
           </p:cNvPr>
@@ -9809,10 +10385,10 @@
       </p:sp>
       <p:pic>
         <p:nvPicPr>
-          <p:cNvPr id="5" name="">
+          <p:cNvPr id="6" name="">
             <a:extLst xmlns:a="http://schemas.openxmlformats.org/drawingml/2006/main">
               <a:ext uri="{FF2B5EF4-FFF2-40B4-BE49-F238E27FC236}">
-                <a16:creationId xmlns:a16="http://schemas.microsoft.com/office/drawing/2014/main" id="{6A7CB3B3-4F24-48BA-B6B5-636A4FA7A101}"/>
+                <a16:creationId xmlns:a16="http://schemas.microsoft.com/office/drawing/2014/main" id="{E57CBE58-8E6C-4140-8AC0-6A9281C1D704}"/>
               </a:ext>
             </a:extLst>
           </p:cNvPr>
@@ -9822,7 +10398,7 @@
           <p:nvPr/>
         </p:nvPicPr>
         <p:blipFill>
-          <a:blip xmlns:r="http://schemas.openxmlformats.org/officeDocument/2006/relationships" xmlns:a="http://schemas.openxmlformats.org/drawingml/2006/main" r:embed="R695c9971f9634f85"/>
+          <a:blip xmlns:r="http://schemas.openxmlformats.org/officeDocument/2006/relationships" xmlns:a="http://schemas.openxmlformats.org/drawingml/2006/main" r:embed="R225593049ccb4d4b"/>
           <a:stretch xmlns:a="http://schemas.openxmlformats.org/drawingml/2006/main"/>
         </p:blipFill>
         <p:spPr>
@@ -9837,10 +10413,10 @@
       </p:pic>
       <p:sp>
         <p:nvSpPr>
-          <p:cNvPr id="6" name="">
+          <p:cNvPr id="7" name="">
             <a:extLst xmlns:a="http://schemas.openxmlformats.org/drawingml/2006/main">
               <a:ext uri="{FF2B5EF4-FFF2-40B4-BE49-F238E27FC236}">
-                <a16:creationId xmlns:a16="http://schemas.microsoft.com/office/drawing/2014/main" id="{7DD45DC2-C814-4051-8C07-AFD208C6BCDE}"/>
+                <a16:creationId xmlns:a16="http://schemas.microsoft.com/office/drawing/2014/main" id="{40F177A4-DD1C-41CE-8A80-FEB9E2E9B823}"/>
               </a:ext>
             </a:extLst>
           </p:cNvPr>
@@ -9907,7 +10483,7 @@
     </p:spTree>
     <p:extLst>
       <p:ext uri="{BB962C8B-B14F-4D97-AF65-F5344CB8AC3E}">
-        <p14:creationId xmlns:p14="http://schemas.microsoft.com/office/powerpoint/2010/main" val="321439508"/>
+        <p14:creationId xmlns:p14="http://schemas.microsoft.com/office/powerpoint/2010/main" val="1090157441"/>
       </p:ext>
     </p:extLst>
   </p:cSld>
@@ -9935,10 +10511,79 @@
       </p:grpSpPr>
       <p:sp>
         <p:nvSpPr>
-          <p:cNvPr id="17" name="slide-title">
+          <p:cNvPr id="18" name="">
             <a:extLst xmlns:a="http://schemas.openxmlformats.org/drawingml/2006/main">
               <a:ext uri="{FF2B5EF4-FFF2-40B4-BE49-F238E27FC236}">
-                <a16:creationId xmlns:a16="http://schemas.microsoft.com/office/drawing/2014/main" id="{9CCF6E53-A1F6-4F5D-B095-076309827B78}"/>
+                <a16:creationId xmlns:a16="http://schemas.microsoft.com/office/drawing/2014/main" id="{8859560D-A113-4E5E-938B-6791FC9CBDFC}"/>
+              </a:ext>
+            </a:extLst>
+          </p:cNvPr>
+          <p:cNvSpPr>
+            <a:spLocks xmlns:a="http://schemas.openxmlformats.org/drawingml/2006/main" noGrp="1"/>
+          </p:cNvSpPr>
+          <p:nvPr/>
+        </p:nvSpPr>
+        <p:spPr>
+          <a:xfrm xmlns:a="http://schemas.openxmlformats.org/drawingml/2006/main">
+            <a:off x="9906000" y="552450"/>
+            <a:ext cx="1600200" cy="228600"/>
+          </a:xfrm>
+          <a:prstGeom xmlns:a="http://schemas.openxmlformats.org/drawingml/2006/main" prst="rect">
+            <a:avLst/>
+          </a:prstGeom>
+          <a:noFill xmlns:a="http://schemas.openxmlformats.org/drawingml/2006/main"/>
+          <a:ln xmlns:a="http://schemas.openxmlformats.org/drawingml/2006/main" w="0">
+            <a:noFill/>
+            <a:prstDash val="solid"/>
+          </a:ln>
+        </p:spPr>
+        <p:txBody>
+          <a:bodyPr xmlns:a="http://schemas.openxmlformats.org/drawingml/2006/main">
+            <a:noAutofit/>
+          </a:bodyPr>
+          <a:lstStyle xmlns:a="http://schemas.openxmlformats.org/drawingml/2006/main">
+            <a:defPPr>
+              <a:defRPr sz="975" b="0">
+                <a:solidFill>
+                  <a:srgbClr val="8A94A3"/>
+                </a:solidFill>
+                <a:latin typeface="Arial"/>
+                <a:ea typeface="Arial"/>
+                <a:cs typeface="Arial"/>
+              </a:defRPr>
+            </a:defPPr>
+          </a:lstStyle>
+          <a:p xmlns:a="http://schemas.openxmlformats.org/drawingml/2006/main">
+            <a:pPr>
+              <a:defRPr sz="975" b="0">
+                <a:solidFill>
+                  <a:srgbClr val="8A94A3"/>
+                </a:solidFill>
+                <a:latin typeface="Arial"/>
+                <a:ea typeface="Arial"/>
+                <a:cs typeface="Arial"/>
+              </a:defRPr>
+            </a:pPr>
+            <a:r>
+              <a:rPr sz="975" b="0">
+                <a:solidFill>
+                  <a:srgbClr val="8A94A3"/>
+                </a:solidFill>
+                <a:latin typeface="Arial"/>
+                <a:ea typeface="Arial"/>
+                <a:cs typeface="Arial"/>
+              </a:rPr>
+              <a:t>9 / 10</a:t>
+            </a:r>
+          </a:p>
+        </p:txBody>
+      </p:sp>
+      <p:sp>
+        <p:nvSpPr>
+          <p:cNvPr id="2" name="slide-title">
+            <a:extLst xmlns:a="http://schemas.openxmlformats.org/drawingml/2006/main">
+              <a:ext uri="{FF2B5EF4-FFF2-40B4-BE49-F238E27FC236}">
+                <a16:creationId xmlns:a16="http://schemas.microsoft.com/office/drawing/2014/main" id="{DA087916-2C03-460D-94E6-8D6AC9561138}"/>
               </a:ext>
             </a:extLst>
           </p:cNvPr>
@@ -10004,10 +10649,10 @@
       </p:sp>
       <p:sp>
         <p:nvSpPr>
-          <p:cNvPr id="2" name="slide-lead">
+          <p:cNvPr id="3" name="slide-lead">
             <a:extLst xmlns:a="http://schemas.openxmlformats.org/drawingml/2006/main">
               <a:ext uri="{FF2B5EF4-FFF2-40B4-BE49-F238E27FC236}">
-                <a16:creationId xmlns:a16="http://schemas.microsoft.com/office/drawing/2014/main" id="{72854574-9AA8-4C68-86D3-95F7FDC9A6D0}"/>
+                <a16:creationId xmlns:a16="http://schemas.microsoft.com/office/drawing/2014/main" id="{0976BC35-3E0E-48B6-A0C1-E48D60CA65C6}"/>
               </a:ext>
             </a:extLst>
           </p:cNvPr>
@@ -10073,10 +10718,10 @@
       </p:sp>
       <p:sp>
         <p:nvSpPr>
-          <p:cNvPr id="3" name="title-rule">
+          <p:cNvPr id="4" name="title-rule">
             <a:extLst xmlns:a="http://schemas.openxmlformats.org/drawingml/2006/main">
               <a:ext uri="{FF2B5EF4-FFF2-40B4-BE49-F238E27FC236}">
-                <a16:creationId xmlns:a16="http://schemas.microsoft.com/office/drawing/2014/main" id="{44D6116A-853C-4296-9CBD-3FFDFE2BF9A3}"/>
+                <a16:creationId xmlns:a16="http://schemas.microsoft.com/office/drawing/2014/main" id="{716DF08B-D282-47B7-9B00-77B80BA68D23}"/>
               </a:ext>
             </a:extLst>
           </p:cNvPr>
@@ -10104,10 +10749,10 @@
       </p:sp>
       <p:sp>
         <p:nvSpPr>
-          <p:cNvPr id="4" name="">
+          <p:cNvPr id="5" name="">
             <a:extLst xmlns:a="http://schemas.openxmlformats.org/drawingml/2006/main">
               <a:ext uri="{FF2B5EF4-FFF2-40B4-BE49-F238E27FC236}">
-                <a16:creationId xmlns:a16="http://schemas.microsoft.com/office/drawing/2014/main" id="{71832D99-F926-44FA-A762-FD7661E9AC57}"/>
+                <a16:creationId xmlns:a16="http://schemas.microsoft.com/office/drawing/2014/main" id="{73366023-FE8B-43F9-8998-27843A7B3FCE}"/>
               </a:ext>
             </a:extLst>
           </p:cNvPr>
@@ -10173,10 +10818,10 @@
       </p:sp>
       <p:sp>
         <p:nvSpPr>
-          <p:cNvPr id="5" name="">
+          <p:cNvPr id="6" name="">
             <a:extLst xmlns:a="http://schemas.openxmlformats.org/drawingml/2006/main">
               <a:ext uri="{FF2B5EF4-FFF2-40B4-BE49-F238E27FC236}">
-                <a16:creationId xmlns:a16="http://schemas.microsoft.com/office/drawing/2014/main" id="{74614E94-B7FC-4CD4-9A42-677A42FBEADD}"/>
+                <a16:creationId xmlns:a16="http://schemas.microsoft.com/office/drawing/2014/main" id="{5B8DC7BA-9147-4860-8299-8254F7B5A848}"/>
               </a:ext>
             </a:extLst>
           </p:cNvPr>
@@ -10242,10 +10887,10 @@
       </p:sp>
       <p:sp>
         <p:nvSpPr>
-          <p:cNvPr id="6" name="">
+          <p:cNvPr id="7" name="">
             <a:extLst xmlns:a="http://schemas.openxmlformats.org/drawingml/2006/main">
               <a:ext uri="{FF2B5EF4-FFF2-40B4-BE49-F238E27FC236}">
-                <a16:creationId xmlns:a16="http://schemas.microsoft.com/office/drawing/2014/main" id="{AE317221-4E94-480E-8555-17F7BCCAB3B3}"/>
+                <a16:creationId xmlns:a16="http://schemas.microsoft.com/office/drawing/2014/main" id="{C53AFBA2-9E2E-407A-A094-3F72833BFB12}"/>
               </a:ext>
             </a:extLst>
           </p:cNvPr>
@@ -10311,10 +10956,10 @@
       </p:sp>
       <p:sp>
         <p:nvSpPr>
-          <p:cNvPr id="7" name="">
+          <p:cNvPr id="8" name="">
             <a:extLst xmlns:a="http://schemas.openxmlformats.org/drawingml/2006/main">
               <a:ext uri="{FF2B5EF4-FFF2-40B4-BE49-F238E27FC236}">
-                <a16:creationId xmlns:a16="http://schemas.microsoft.com/office/drawing/2014/main" id="{C4F6E19D-BC51-48D3-8B4A-75F3603A4AEC}"/>
+                <a16:creationId xmlns:a16="http://schemas.microsoft.com/office/drawing/2014/main" id="{8B28DE9D-0958-4560-9DCD-F00D1EFB9358}"/>
               </a:ext>
             </a:extLst>
           </p:cNvPr>
@@ -10380,10 +11025,10 @@
       </p:sp>
       <p:sp>
         <p:nvSpPr>
-          <p:cNvPr id="8" name="">
+          <p:cNvPr id="9" name="">
             <a:extLst xmlns:a="http://schemas.openxmlformats.org/drawingml/2006/main">
               <a:ext uri="{FF2B5EF4-FFF2-40B4-BE49-F238E27FC236}">
-                <a16:creationId xmlns:a16="http://schemas.microsoft.com/office/drawing/2014/main" id="{E5343CE7-4966-4B59-BAB2-53D4A0C368B2}"/>
+                <a16:creationId xmlns:a16="http://schemas.microsoft.com/office/drawing/2014/main" id="{0E08F124-5C4D-44AC-A992-B21090419F93}"/>
               </a:ext>
             </a:extLst>
           </p:cNvPr>
@@ -10449,10 +11094,10 @@
       </p:sp>
       <p:sp>
         <p:nvSpPr>
-          <p:cNvPr id="9" name="">
+          <p:cNvPr id="10" name="">
             <a:extLst xmlns:a="http://schemas.openxmlformats.org/drawingml/2006/main">
               <a:ext uri="{FF2B5EF4-FFF2-40B4-BE49-F238E27FC236}">
-                <a16:creationId xmlns:a16="http://schemas.microsoft.com/office/drawing/2014/main" id="{44AB3A78-DAF7-41B3-BD72-736B6A9488DC}"/>
+                <a16:creationId xmlns:a16="http://schemas.microsoft.com/office/drawing/2014/main" id="{BDAF4D86-8686-4820-8F5B-CC0AD2732D78}"/>
               </a:ext>
             </a:extLst>
           </p:cNvPr>
@@ -10518,10 +11163,10 @@
       </p:sp>
       <p:sp>
         <p:nvSpPr>
-          <p:cNvPr id="10" name="">
+          <p:cNvPr id="11" name="">
             <a:extLst xmlns:a="http://schemas.openxmlformats.org/drawingml/2006/main">
               <a:ext uri="{FF2B5EF4-FFF2-40B4-BE49-F238E27FC236}">
-                <a16:creationId xmlns:a16="http://schemas.microsoft.com/office/drawing/2014/main" id="{89EFD438-7D78-4FBD-B1EE-1D9E075A604B}"/>
+                <a16:creationId xmlns:a16="http://schemas.microsoft.com/office/drawing/2014/main" id="{2AE901AE-9E8D-4132-B14C-75F0895B9EF4}"/>
               </a:ext>
             </a:extLst>
           </p:cNvPr>
@@ -10587,10 +11232,10 @@
       </p:sp>
       <p:sp>
         <p:nvSpPr>
-          <p:cNvPr id="11" name="">
+          <p:cNvPr id="12" name="">
             <a:extLst xmlns:a="http://schemas.openxmlformats.org/drawingml/2006/main">
               <a:ext uri="{FF2B5EF4-FFF2-40B4-BE49-F238E27FC236}">
-                <a16:creationId xmlns:a16="http://schemas.microsoft.com/office/drawing/2014/main" id="{E85B8BA8-DE25-4EF3-BF77-AE43BE130654}"/>
+                <a16:creationId xmlns:a16="http://schemas.microsoft.com/office/drawing/2014/main" id="{6119F18B-85EB-4C34-8D8A-595F6B8DD2A6}"/>
               </a:ext>
             </a:extLst>
           </p:cNvPr>
@@ -10656,10 +11301,10 @@
       </p:sp>
       <p:sp>
         <p:nvSpPr>
-          <p:cNvPr id="12" name="">
+          <p:cNvPr id="13" name="">
             <a:extLst xmlns:a="http://schemas.openxmlformats.org/drawingml/2006/main">
               <a:ext uri="{FF2B5EF4-FFF2-40B4-BE49-F238E27FC236}">
-                <a16:creationId xmlns:a16="http://schemas.microsoft.com/office/drawing/2014/main" id="{5DD5B215-A11F-438B-A2AE-AE2C7E72A168}"/>
+                <a16:creationId xmlns:a16="http://schemas.microsoft.com/office/drawing/2014/main" id="{96CE4052-0E40-4114-AE02-10D3364ECE92}"/>
               </a:ext>
             </a:extLst>
           </p:cNvPr>
@@ -10725,10 +11370,10 @@
       </p:sp>
       <p:sp>
         <p:nvSpPr>
-          <p:cNvPr id="13" name="">
+          <p:cNvPr id="14" name="">
             <a:extLst xmlns:a="http://schemas.openxmlformats.org/drawingml/2006/main">
               <a:ext uri="{FF2B5EF4-FFF2-40B4-BE49-F238E27FC236}">
-                <a16:creationId xmlns:a16="http://schemas.microsoft.com/office/drawing/2014/main" id="{F18C581C-08CB-48C4-8649-0F1F0538AA66}"/>
+                <a16:creationId xmlns:a16="http://schemas.microsoft.com/office/drawing/2014/main" id="{795EE869-5F43-4883-9E8D-7BC081507D91}"/>
               </a:ext>
             </a:extLst>
           </p:cNvPr>
@@ -10794,10 +11439,10 @@
       </p:sp>
       <p:sp>
         <p:nvSpPr>
-          <p:cNvPr id="14" name="">
+          <p:cNvPr id="15" name="">
             <a:extLst xmlns:a="http://schemas.openxmlformats.org/drawingml/2006/main">
               <a:ext uri="{FF2B5EF4-FFF2-40B4-BE49-F238E27FC236}">
-                <a16:creationId xmlns:a16="http://schemas.microsoft.com/office/drawing/2014/main" id="{204F20CD-88C8-41E8-B21C-1E21F5C0F29D}"/>
+                <a16:creationId xmlns:a16="http://schemas.microsoft.com/office/drawing/2014/main" id="{47A911F2-F7C8-4063-A76B-41170D34D87B}"/>
               </a:ext>
             </a:extLst>
           </p:cNvPr>
@@ -10863,10 +11508,10 @@
       </p:sp>
       <p:sp>
         <p:nvSpPr>
-          <p:cNvPr id="15" name="">
+          <p:cNvPr id="16" name="">
             <a:extLst xmlns:a="http://schemas.openxmlformats.org/drawingml/2006/main">
               <a:ext uri="{FF2B5EF4-FFF2-40B4-BE49-F238E27FC236}">
-                <a16:creationId xmlns:a16="http://schemas.microsoft.com/office/drawing/2014/main" id="{D75B94A0-5081-49A9-8682-EF4581C78519}"/>
+                <a16:creationId xmlns:a16="http://schemas.microsoft.com/office/drawing/2014/main" id="{D87AA2DA-3D24-48E0-9BF4-EF3186431D63}"/>
               </a:ext>
             </a:extLst>
           </p:cNvPr>
@@ -10932,10 +11577,10 @@
       </p:sp>
       <p:sp>
         <p:nvSpPr>
-          <p:cNvPr id="16" name="">
+          <p:cNvPr id="17" name="">
             <a:extLst xmlns:a="http://schemas.openxmlformats.org/drawingml/2006/main">
               <a:ext uri="{FF2B5EF4-FFF2-40B4-BE49-F238E27FC236}">
-                <a16:creationId xmlns:a16="http://schemas.microsoft.com/office/drawing/2014/main" id="{AE654176-CC5A-4F60-88DF-3C6E3EFE2256}"/>
+                <a16:creationId xmlns:a16="http://schemas.microsoft.com/office/drawing/2014/main" id="{E7C77AFE-5E8E-4C30-877C-0942A679C950}"/>
               </a:ext>
             </a:extLst>
           </p:cNvPr>
@@ -11060,7 +11705,7 @@
     </p:spTree>
     <p:extLst>
       <p:ext uri="{BB962C8B-B14F-4D97-AF65-F5344CB8AC3E}">
-        <p14:creationId xmlns:p14="http://schemas.microsoft.com/office/powerpoint/2010/main" val="1427507030"/>
+        <p14:creationId xmlns:p14="http://schemas.microsoft.com/office/powerpoint/2010/main" val="582891391"/>
       </p:ext>
     </p:extLst>
   </p:cSld>

</xml_diff>